<commit_message>
docs: update presentation with Layer-2 judge-panel agreement slide
</commit_message>
<xml_diff>
--- a/docs/DeepResearchAgent.pptx
+++ b/docs/DeepResearchAgent.pptx
@@ -5,7 +5,7 @@
     <p:sldMasterId id="2147483648" r:id="rId1"/>
   </p:sldMasterIdLst>
   <p:notesMasterIdLst>
-    <p:notesMasterId r:id="rId33"/>
+    <p:notesMasterId r:id="rId34"/>
   </p:notesMasterIdLst>
   <p:sldIdLst>
     <p:sldId id="256" r:id="rId2"/>
@@ -28,17 +28,18 @@
     <p:sldId id="274" r:id="rId19"/>
     <p:sldId id="275" r:id="rId20"/>
     <p:sldId id="276" r:id="rId21"/>
-    <p:sldId id="277" r:id="rId22"/>
-    <p:sldId id="262" r:id="rId23"/>
-    <p:sldId id="278" r:id="rId24"/>
-    <p:sldId id="279" r:id="rId25"/>
-    <p:sldId id="280" r:id="rId26"/>
-    <p:sldId id="281" r:id="rId27"/>
-    <p:sldId id="282" r:id="rId28"/>
-    <p:sldId id="283" r:id="rId29"/>
-    <p:sldId id="284" r:id="rId30"/>
-    <p:sldId id="285" r:id="rId31"/>
-    <p:sldId id="286" r:id="rId32"/>
+    <p:sldId id="287" r:id="rId22"/>
+    <p:sldId id="277" r:id="rId23"/>
+    <p:sldId id="262" r:id="rId24"/>
+    <p:sldId id="278" r:id="rId25"/>
+    <p:sldId id="279" r:id="rId26"/>
+    <p:sldId id="280" r:id="rId27"/>
+    <p:sldId id="281" r:id="rId28"/>
+    <p:sldId id="282" r:id="rId29"/>
+    <p:sldId id="283" r:id="rId30"/>
+    <p:sldId id="284" r:id="rId31"/>
+    <p:sldId id="285" r:id="rId32"/>
+    <p:sldId id="286" r:id="rId33"/>
   </p:sldIdLst>
   <p:sldSz cx="12192000" cy="6858000"/>
   <p:notesSz cx="6858000" cy="12192000"/>
@@ -3839,7 +3840,7 @@
           <a:p>
             <a:fld id="{F7021451-1387-4CA6-816F-3879F97B5CBC}" type="slidenum">
               <a:rPr lang="en-US"/>
-              <a:t>21</a:t>
+              <a:t>22</a:t>
             </a:fld>
             <a:endParaRPr lang="en-US"/>
           </a:p>
@@ -3923,7 +3924,7 @@
           <a:p>
             <a:fld id="{F7021451-1387-4CA6-816F-3879F97B5CBC}" type="slidenum">
               <a:rPr lang="en-US"/>
-              <a:t>22</a:t>
+              <a:t>23</a:t>
             </a:fld>
             <a:endParaRPr lang="en-US"/>
           </a:p>
@@ -4007,7 +4008,7 @@
           <a:p>
             <a:fld id="{F7021451-1387-4CA6-816F-3879F97B5CBC}" type="slidenum">
               <a:rPr lang="en-US"/>
-              <a:t>23</a:t>
+              <a:t>24</a:t>
             </a:fld>
             <a:endParaRPr lang="en-US"/>
           </a:p>
@@ -4091,7 +4092,7 @@
           <a:p>
             <a:fld id="{F7021451-1387-4CA6-816F-3879F97B5CBC}" type="slidenum">
               <a:rPr lang="en-US"/>
-              <a:t>24</a:t>
+              <a:t>25</a:t>
             </a:fld>
             <a:endParaRPr lang="en-US"/>
           </a:p>
@@ -4175,7 +4176,7 @@
           <a:p>
             <a:fld id="{F7021451-1387-4CA6-816F-3879F97B5CBC}" type="slidenum">
               <a:rPr lang="en-US"/>
-              <a:t>25</a:t>
+              <a:t>26</a:t>
             </a:fld>
             <a:endParaRPr lang="en-US"/>
           </a:p>
@@ -4259,7 +4260,7 @@
           <a:p>
             <a:fld id="{F7021451-1387-4CA6-816F-3879F97B5CBC}" type="slidenum">
               <a:rPr lang="en-US"/>
-              <a:t>26</a:t>
+              <a:t>27</a:t>
             </a:fld>
             <a:endParaRPr lang="en-US"/>
           </a:p>
@@ -4343,7 +4344,7 @@
           <a:p>
             <a:fld id="{F7021451-1387-4CA6-816F-3879F97B5CBC}" type="slidenum">
               <a:rPr lang="en-US"/>
-              <a:t>27</a:t>
+              <a:t>28</a:t>
             </a:fld>
             <a:endParaRPr lang="en-US"/>
           </a:p>
@@ -4427,7 +4428,7 @@
           <a:p>
             <a:fld id="{F7021451-1387-4CA6-816F-3879F97B5CBC}" type="slidenum">
               <a:rPr lang="en-US"/>
-              <a:t>28</a:t>
+              <a:t>29</a:t>
             </a:fld>
             <a:endParaRPr lang="en-US"/>
           </a:p>
@@ -4511,7 +4512,7 @@
           <a:p>
             <a:fld id="{F7021451-1387-4CA6-816F-3879F97B5CBC}" type="slidenum">
               <a:rPr lang="en-US"/>
-              <a:t>29</a:t>
+              <a:t>30</a:t>
             </a:fld>
             <a:endParaRPr lang="en-US"/>
           </a:p>
@@ -4679,7 +4680,7 @@
           <a:p>
             <a:fld id="{F7021451-1387-4CA6-816F-3879F97B5CBC}" type="slidenum">
               <a:rPr lang="en-US"/>
-              <a:t>30</a:t>
+              <a:t>31</a:t>
             </a:fld>
             <a:endParaRPr lang="en-US"/>
           </a:p>
@@ -4763,7 +4764,7 @@
           <a:p>
             <a:fld id="{F7021451-1387-4CA6-816F-3879F97B5CBC}" type="slidenum">
               <a:rPr lang="en-US"/>
-              <a:t>31</a:t>
+              <a:t>32</a:t>
             </a:fld>
             <a:endParaRPr lang="en-US"/>
           </a:p>
@@ -20693,6 +20694,2213 @@
 
 <file path=ppt/slides/slide21.xml><?xml version="1.0" encoding="utf-8"?>
 <p:sld xmlns:a="http://schemas.openxmlformats.org/drawingml/2006/main" xmlns:r="http://schemas.openxmlformats.org/officeDocument/2006/relationships" xmlns:p="http://schemas.openxmlformats.org/presentationml/2006/main">
+  <p:cSld>
+    <p:bg>
+      <p:bgPr>
+        <a:solidFill>
+          <a:srgbClr val="F4F6F9"/>
+        </a:solidFill>
+        <a:effectLst/>
+      </p:bgPr>
+    </p:bg>
+    <p:spTree>
+      <p:nvGrpSpPr>
+        <p:cNvPr id="1" name=""/>
+        <p:cNvGrpSpPr/>
+        <p:nvPr/>
+      </p:nvGrpSpPr>
+      <p:grpSpPr>
+        <a:xfrm>
+          <a:off x="0" y="0"/>
+          <a:ext cx="0" cy="0"/>
+          <a:chOff x="0" y="0"/>
+          <a:chExt cx="0" cy="0"/>
+        </a:xfrm>
+      </p:grpSpPr>
+      <p:sp>
+        <p:nvSpPr>
+          <p:cNvPr id="900" name="Shape 0"/>
+          <p:cNvSpPr/>
+          <p:nvPr/>
+        </p:nvSpPr>
+        <p:spPr>
+          <a:xfrm>
+            <a:off x="640080" y="475488"/>
+            <a:ext cx="329184" cy="329184"/>
+          </a:xfrm>
+          <a:prstGeom prst="roundRect">
+            <a:avLst>
+              <a:gd name="adj" fmla="val 19444"/>
+            </a:avLst>
+          </a:prstGeom>
+          <a:solidFill>
+            <a:srgbClr val="0D9488"/>
+          </a:solidFill>
+          <a:ln/>
+        </p:spPr>
+        <p:txBody>
+          <a:bodyPr/>
+          <a:lstStyle/>
+          <a:p>
+            <a:endParaRPr lang="en-US"/>
+          </a:p>
+        </p:txBody>
+      </p:sp>
+      <p:sp>
+        <p:nvSpPr>
+          <p:cNvPr id="901" name="Text 1"/>
+          <p:cNvSpPr/>
+          <p:nvPr/>
+        </p:nvSpPr>
+        <p:spPr>
+          <a:xfrm>
+            <a:off x="640080" y="475488"/>
+            <a:ext cx="329184" cy="329184"/>
+          </a:xfrm>
+          <a:prstGeom prst="rect">
+            <a:avLst/>
+          </a:prstGeom>
+          <a:noFill/>
+          <a:ln/>
+        </p:spPr>
+        <p:txBody>
+          <a:bodyPr wrap="square" lIns="0" tIns="0" rIns="0" bIns="0" rtlCol="0" anchor="ctr"/>
+          <a:lstStyle/>
+          <a:p>
+            <a:pPr marL="0" indent="0" algn="ctr">
+              <a:buNone/>
+            </a:pPr>
+            <a:r>
+              <a:rPr lang="en-US" sz="1500" b="1" dirty="0">
+                <a:solidFill>
+                  <a:srgbClr val="FFFFFF"/>
+                </a:solidFill>
+                <a:latin typeface="Calibri" pitchFamily="34" charset="0"/>
+                <a:ea typeface="Calibri" pitchFamily="34" charset="-122"/>
+                <a:cs typeface="Calibri" pitchFamily="34" charset="-120"/>
+              </a:rPr>
+              <a:t>7</a:t>
+            </a:r>
+            <a:endParaRPr lang="en-US" sz="1500" dirty="0"/>
+          </a:p>
+        </p:txBody>
+      </p:sp>
+      <p:sp>
+        <p:nvSpPr>
+          <p:cNvPr id="902" name="Text 2"/>
+          <p:cNvSpPr/>
+          <p:nvPr/>
+        </p:nvSpPr>
+        <p:spPr>
+          <a:xfrm>
+            <a:off x="1097280" y="475488"/>
+            <a:ext cx="8229600" cy="329184"/>
+          </a:xfrm>
+          <a:prstGeom prst="rect">
+            <a:avLst/>
+          </a:prstGeom>
+          <a:noFill/>
+          <a:ln/>
+        </p:spPr>
+        <p:txBody>
+          <a:bodyPr wrap="square" lIns="0" tIns="0" rIns="0" bIns="0" rtlCol="0" anchor="ctr"/>
+          <a:lstStyle/>
+          <a:p>
+            <a:pPr marL="0" indent="0">
+              <a:buNone/>
+            </a:pPr>
+            <a:r>
+              <a:rPr lang="en-US" sz="1250" b="1" kern="0" spc="240" dirty="0">
+                <a:solidFill>
+                  <a:srgbClr val="0D9488"/>
+                </a:solidFill>
+                <a:latin typeface="Calibri" pitchFamily="34" charset="0"/>
+                <a:ea typeface="Calibri" pitchFamily="34" charset="-122"/>
+                <a:cs typeface="Calibri" pitchFamily="34" charset="-120"/>
+              </a:rPr>
+              <a:t>EVALUATION — RESULTS</a:t>
+            </a:r>
+            <a:endParaRPr lang="en-US" sz="1250" dirty="0"/>
+          </a:p>
+        </p:txBody>
+      </p:sp>
+      <p:sp>
+        <p:nvSpPr>
+          <p:cNvPr id="6" name="TextBox 5"/>
+          <p:cNvSpPr txBox="1"/>
+          <p:nvPr/>
+        </p:nvSpPr>
+        <p:spPr>
+          <a:xfrm>
+            <a:off x="640080" y="841248"/>
+            <a:ext cx="10911535" cy="822960"/>
+          </a:xfrm>
+          <a:prstGeom prst="rect">
+            <a:avLst/>
+          </a:prstGeom>
+          <a:noFill/>
+        </p:spPr>
+        <p:txBody>
+          <a:bodyPr wrap="square" anchor="t">
+            <a:spAutoFit/>
+          </a:bodyPr>
+          <a:lstStyle/>
+          <a:p>
+            <a:pPr algn="l">
+              <a:spcAft>
+                <a:spcPts val="400"/>
+              </a:spcAft>
+            </a:pPr>
+            <a:r>
+              <a:rPr sz="2600" b="1">
+                <a:solidFill>
+                  <a:srgbClr val="16202E"/>
+                </a:solidFill>
+                <a:latin typeface="Calibri"/>
+              </a:rPr>
+              <a:t>Layer-2 — DRA-Bench: how much do the three judges agree?</a:t>
+            </a:r>
+          </a:p>
+        </p:txBody>
+      </p:sp>
+      <p:sp>
+        <p:nvSpPr>
+          <p:cNvPr id="7" name="TextBox 6"/>
+          <p:cNvSpPr txBox="1"/>
+          <p:nvPr/>
+        </p:nvSpPr>
+        <p:spPr>
+          <a:xfrm>
+            <a:off x="640080" y="1770000"/>
+            <a:ext cx="10911535" cy="440000"/>
+          </a:xfrm>
+          <a:prstGeom prst="rect">
+            <a:avLst/>
+          </a:prstGeom>
+          <a:noFill/>
+        </p:spPr>
+        <p:txBody>
+          <a:bodyPr wrap="square" anchor="t">
+            <a:spAutoFit/>
+          </a:bodyPr>
+          <a:lstStyle/>
+          <a:p>
+            <a:pPr algn="l">
+              <a:spcAft>
+                <a:spcPts val="400"/>
+              </a:spcAft>
+            </a:pPr>
+            <a:r>
+              <a:rPr sz="1300" b="0">
+                <a:solidFill>
+                  <a:srgbClr val="16202E"/>
+                </a:solidFill>
+                <a:latin typeface="Calibri"/>
+              </a:rPr>
+              <a:t>Relevance &amp; Quality are scored by a 3-judge panel </a:t>
+            </a:r>
+            <a:r>
+              <a:rPr sz="1300" b="0">
+                <a:solidFill>
+                  <a:srgbClr val="566576"/>
+                </a:solidFill>
+                <a:latin typeface="Calibri"/>
+              </a:rPr>
+              <a:t>(GPT-OSS 120B · Opus 4.8 · DeepSeek R1)</a:t>
+            </a:r>
+            <a:r>
+              <a:rPr sz="1300" b="0">
+                <a:solidFill>
+                  <a:srgbClr val="16202E"/>
+                </a:solidFill>
+                <a:latin typeface="Calibri"/>
+              </a:rPr>
+              <a:t>  —  inter-judge agreement over 238 v0 reports:</a:t>
+            </a:r>
+          </a:p>
+        </p:txBody>
+      </p:sp>
+      <p:sp>
+        <p:nvSpPr>
+          <p:cNvPr id="8" name="TextBox 7"/>
+          <p:cNvSpPr txBox="1"/>
+          <p:nvPr/>
+        </p:nvSpPr>
+        <p:spPr>
+          <a:xfrm>
+            <a:off x="640080" y="2290000"/>
+            <a:ext cx="10911535" cy="274320"/>
+          </a:xfrm>
+          <a:prstGeom prst="rect">
+            <a:avLst/>
+          </a:prstGeom>
+          <a:noFill/>
+        </p:spPr>
+        <p:txBody>
+          <a:bodyPr wrap="square" anchor="t">
+            <a:spAutoFit/>
+          </a:bodyPr>
+          <a:lstStyle/>
+          <a:p>
+            <a:pPr algn="l">
+              <a:spcAft>
+                <a:spcPts val="400"/>
+              </a:spcAft>
+            </a:pPr>
+            <a:r>
+              <a:rPr sz="1200" b="1">
+                <a:solidFill>
+                  <a:srgbClr val="0D9488"/>
+                </a:solidFill>
+                <a:latin typeface="Calibri"/>
+              </a:rPr>
+              <a:t>PER-JUDGE DISAGREEMENT RATE   (score ≠ panel majority)</a:t>
+            </a:r>
+          </a:p>
+        </p:txBody>
+      </p:sp>
+      <p:graphicFrame>
+        <p:nvGraphicFramePr>
+          <p:cNvPr id="9" name="Table 8"/>
+          <p:cNvGraphicFramePr>
+            <a:graphicFrameLocks noGrp="1"/>
+          </p:cNvGraphicFramePr>
+          <p:nvPr/>
+        </p:nvGraphicFramePr>
+        <p:xfrm>
+          <a:off x="640080" y="2610000"/>
+          <a:ext cx="6400800" cy="1280000"/>
+        </p:xfrm>
+        <a:graphic>
+          <a:graphicData uri="http://schemas.openxmlformats.org/drawingml/2006/table">
+            <a:tbl>
+              <a:tblPr/>
+              <a:tblGrid>
+                <a:gridCol w="3200400">
+                  <a:extLst>
+                    <a:ext uri="{9D8B030D-6E8A-4147-A177-3AD203B41FA5}">
+                      <a16:colId xmlns:a16="http://schemas.microsoft.com/office/drawing/2014/main" val="20000"/>
+                    </a:ext>
+                  </a:extLst>
+                </a:gridCol>
+                <a:gridCol w="1600200">
+                  <a:extLst>
+                    <a:ext uri="{9D8B030D-6E8A-4147-A177-3AD203B41FA5}">
+                      <a16:colId xmlns:a16="http://schemas.microsoft.com/office/drawing/2014/main" val="20001"/>
+                    </a:ext>
+                  </a:extLst>
+                </a:gridCol>
+                <a:gridCol w="1600200">
+                  <a:extLst>
+                    <a:ext uri="{9D8B030D-6E8A-4147-A177-3AD203B41FA5}">
+                      <a16:colId xmlns:a16="http://schemas.microsoft.com/office/drawing/2014/main" val="20002"/>
+                    </a:ext>
+                  </a:extLst>
+                </a:gridCol>
+              </a:tblGrid>
+              <a:tr h="320000">
+                <a:tc>
+                  <a:txBody>
+                    <a:bodyPr/>
+                    <a:lstStyle/>
+                    <a:p>
+                      <a:pPr marL="0" indent="0" algn="l">
+                        <a:buNone/>
+                      </a:pPr>
+                      <a:r>
+                        <a:rPr lang="en-US" sz="1100" b="1" dirty="0">
+                          <a:solidFill>
+                            <a:srgbClr val="EAF0F7"/>
+                          </a:solidFill>
+                          <a:latin typeface="Calibri" pitchFamily="34" charset="0"/>
+                          <a:ea typeface="Calibri" pitchFamily="34" charset="-122"/>
+                          <a:cs typeface="Calibri" pitchFamily="34" charset="-120"/>
+                        </a:rPr>
+                        <a:t>Judge</a:t>
+                      </a:r>
+                      <a:endParaRPr lang="en-US" sz="1100" dirty="0"/>
+                    </a:p>
+                  </a:txBody>
+                  <a:tcPr marL="101600" marR="101600" marT="50800" marB="50800" anchor="ctr">
+                    <a:lnL w="6350" cap="flat" cmpd="sng" algn="ctr">
+                      <a:solidFill>
+                        <a:srgbClr val="D6DEE7"/>
+                      </a:solidFill>
+                      <a:prstDash val="solid"/>
+                      <a:round/>
+                      <a:headEnd type="none" w="med" len="med"/>
+                      <a:tailEnd type="none" w="med" len="med"/>
+                    </a:lnL>
+                    <a:lnR w="6350" cap="flat" cmpd="sng" algn="ctr">
+                      <a:solidFill>
+                        <a:srgbClr val="D6DEE7"/>
+                      </a:solidFill>
+                      <a:prstDash val="solid"/>
+                      <a:round/>
+                      <a:headEnd type="none" w="med" len="med"/>
+                      <a:tailEnd type="none" w="med" len="med"/>
+                    </a:lnR>
+                    <a:lnT w="6350" cap="flat" cmpd="sng" algn="ctr">
+                      <a:solidFill>
+                        <a:srgbClr val="D6DEE7"/>
+                      </a:solidFill>
+                      <a:prstDash val="solid"/>
+                      <a:round/>
+                      <a:headEnd type="none" w="med" len="med"/>
+                      <a:tailEnd type="none" w="med" len="med"/>
+                    </a:lnT>
+                    <a:lnB w="6350" cap="flat" cmpd="sng" algn="ctr">
+                      <a:solidFill>
+                        <a:srgbClr val="D6DEE7"/>
+                      </a:solidFill>
+                      <a:prstDash val="solid"/>
+                      <a:round/>
+                      <a:headEnd type="none" w="med" len="med"/>
+                      <a:tailEnd type="none" w="med" len="med"/>
+                    </a:lnB>
+                    <a:solidFill>
+                      <a:srgbClr val="1E2A3A"/>
+                    </a:solidFill>
+                  </a:tcPr>
+                </a:tc>
+                <a:tc>
+                  <a:txBody>
+                    <a:bodyPr/>
+                    <a:lstStyle/>
+                    <a:p>
+                      <a:pPr marL="0" indent="0" algn="l">
+                        <a:buNone/>
+                      </a:pPr>
+                      <a:r>
+                        <a:rPr lang="en-US" sz="1100" b="1" dirty="0">
+                          <a:solidFill>
+                            <a:srgbClr val="EAF0F7"/>
+                          </a:solidFill>
+                          <a:latin typeface="Calibri" pitchFamily="34" charset="0"/>
+                          <a:ea typeface="Calibri" pitchFamily="34" charset="-122"/>
+                          <a:cs typeface="Calibri" pitchFamily="34" charset="-120"/>
+                        </a:rPr>
+                        <a:t>Relevance</a:t>
+                      </a:r>
+                      <a:endParaRPr lang="en-US" sz="1100" dirty="0"/>
+                    </a:p>
+                  </a:txBody>
+                  <a:tcPr marL="101600" marR="101600" marT="50800" marB="50800" anchor="ctr">
+                    <a:lnL w="6350" cap="flat" cmpd="sng" algn="ctr">
+                      <a:solidFill>
+                        <a:srgbClr val="D6DEE7"/>
+                      </a:solidFill>
+                      <a:prstDash val="solid"/>
+                      <a:round/>
+                      <a:headEnd type="none" w="med" len="med"/>
+                      <a:tailEnd type="none" w="med" len="med"/>
+                    </a:lnL>
+                    <a:lnR w="6350" cap="flat" cmpd="sng" algn="ctr">
+                      <a:solidFill>
+                        <a:srgbClr val="D6DEE7"/>
+                      </a:solidFill>
+                      <a:prstDash val="solid"/>
+                      <a:round/>
+                      <a:headEnd type="none" w="med" len="med"/>
+                      <a:tailEnd type="none" w="med" len="med"/>
+                    </a:lnR>
+                    <a:lnT w="6350" cap="flat" cmpd="sng" algn="ctr">
+                      <a:solidFill>
+                        <a:srgbClr val="D6DEE7"/>
+                      </a:solidFill>
+                      <a:prstDash val="solid"/>
+                      <a:round/>
+                      <a:headEnd type="none" w="med" len="med"/>
+                      <a:tailEnd type="none" w="med" len="med"/>
+                    </a:lnT>
+                    <a:lnB w="6350" cap="flat" cmpd="sng" algn="ctr">
+                      <a:solidFill>
+                        <a:srgbClr val="D6DEE7"/>
+                      </a:solidFill>
+                      <a:prstDash val="solid"/>
+                      <a:round/>
+                      <a:headEnd type="none" w="med" len="med"/>
+                      <a:tailEnd type="none" w="med" len="med"/>
+                    </a:lnB>
+                    <a:solidFill>
+                      <a:srgbClr val="1E2A3A"/>
+                    </a:solidFill>
+                  </a:tcPr>
+                </a:tc>
+                <a:tc>
+                  <a:txBody>
+                    <a:bodyPr/>
+                    <a:lstStyle/>
+                    <a:p>
+                      <a:pPr marL="0" indent="0" algn="l">
+                        <a:buNone/>
+                      </a:pPr>
+                      <a:r>
+                        <a:rPr lang="en-US" sz="1100" b="1" dirty="0">
+                          <a:solidFill>
+                            <a:srgbClr val="EAF0F7"/>
+                          </a:solidFill>
+                          <a:latin typeface="Calibri" pitchFamily="34" charset="0"/>
+                          <a:ea typeface="Calibri" pitchFamily="34" charset="-122"/>
+                          <a:cs typeface="Calibri" pitchFamily="34" charset="-120"/>
+                        </a:rPr>
+                        <a:t>Quality</a:t>
+                      </a:r>
+                      <a:endParaRPr lang="en-US" sz="1100" dirty="0"/>
+                    </a:p>
+                  </a:txBody>
+                  <a:tcPr marL="101600" marR="101600" marT="50800" marB="50800" anchor="ctr">
+                    <a:lnL w="6350" cap="flat" cmpd="sng" algn="ctr">
+                      <a:solidFill>
+                        <a:srgbClr val="D6DEE7"/>
+                      </a:solidFill>
+                      <a:prstDash val="solid"/>
+                      <a:round/>
+                      <a:headEnd type="none" w="med" len="med"/>
+                      <a:tailEnd type="none" w="med" len="med"/>
+                    </a:lnL>
+                    <a:lnR w="6350" cap="flat" cmpd="sng" algn="ctr">
+                      <a:solidFill>
+                        <a:srgbClr val="D6DEE7"/>
+                      </a:solidFill>
+                      <a:prstDash val="solid"/>
+                      <a:round/>
+                      <a:headEnd type="none" w="med" len="med"/>
+                      <a:tailEnd type="none" w="med" len="med"/>
+                    </a:lnR>
+                    <a:lnT w="6350" cap="flat" cmpd="sng" algn="ctr">
+                      <a:solidFill>
+                        <a:srgbClr val="D6DEE7"/>
+                      </a:solidFill>
+                      <a:prstDash val="solid"/>
+                      <a:round/>
+                      <a:headEnd type="none" w="med" len="med"/>
+                      <a:tailEnd type="none" w="med" len="med"/>
+                    </a:lnT>
+                    <a:lnB w="6350" cap="flat" cmpd="sng" algn="ctr">
+                      <a:solidFill>
+                        <a:srgbClr val="D6DEE7"/>
+                      </a:solidFill>
+                      <a:prstDash val="solid"/>
+                      <a:round/>
+                      <a:headEnd type="none" w="med" len="med"/>
+                      <a:tailEnd type="none" w="med" len="med"/>
+                    </a:lnB>
+                    <a:solidFill>
+                      <a:srgbClr val="1E2A3A"/>
+                    </a:solidFill>
+                  </a:tcPr>
+                </a:tc>
+                <a:extLst>
+                  <a:ext uri="{0D108BD9-81ED-4DB2-BD59-A6C34878D82A}">
+                    <a16:rowId xmlns:a16="http://schemas.microsoft.com/office/drawing/2014/main" val="10000"/>
+                  </a:ext>
+                </a:extLst>
+              </a:tr>
+              <a:tr h="320000">
+                <a:tc>
+                  <a:txBody>
+                    <a:bodyPr/>
+                    <a:lstStyle/>
+                    <a:p>
+                      <a:pPr marL="0" indent="0" algn="l">
+                        <a:buNone/>
+                      </a:pPr>
+                      <a:r>
+                        <a:rPr lang="en-US" sz="1100" b="1" dirty="0">
+                          <a:solidFill>
+                            <a:srgbClr val="16202E"/>
+                          </a:solidFill>
+                          <a:latin typeface="Calibri" pitchFamily="34" charset="0"/>
+                          <a:ea typeface="Calibri" pitchFamily="34" charset="-122"/>
+                          <a:cs typeface="Calibri" pitchFamily="34" charset="-120"/>
+                        </a:rPr>
+                        <a:t>GPT-OSS 120B</a:t>
+                      </a:r>
+                      <a:endParaRPr lang="en-US" sz="1100" dirty="0"/>
+                    </a:p>
+                  </a:txBody>
+                  <a:tcPr marL="101600" marR="101600" marT="50800" marB="50800" anchor="ctr">
+                    <a:lnL w="6350" cap="flat" cmpd="sng" algn="ctr">
+                      <a:solidFill>
+                        <a:srgbClr val="D6DEE7"/>
+                      </a:solidFill>
+                      <a:prstDash val="solid"/>
+                      <a:round/>
+                      <a:headEnd type="none" w="med" len="med"/>
+                      <a:tailEnd type="none" w="med" len="med"/>
+                    </a:lnL>
+                    <a:lnR w="6350" cap="flat" cmpd="sng" algn="ctr">
+                      <a:solidFill>
+                        <a:srgbClr val="D6DEE7"/>
+                      </a:solidFill>
+                      <a:prstDash val="solid"/>
+                      <a:round/>
+                      <a:headEnd type="none" w="med" len="med"/>
+                      <a:tailEnd type="none" w="med" len="med"/>
+                    </a:lnR>
+                    <a:lnT w="6350" cap="flat" cmpd="sng" algn="ctr">
+                      <a:solidFill>
+                        <a:srgbClr val="D6DEE7"/>
+                      </a:solidFill>
+                      <a:prstDash val="solid"/>
+                      <a:round/>
+                      <a:headEnd type="none" w="med" len="med"/>
+                      <a:tailEnd type="none" w="med" len="med"/>
+                    </a:lnT>
+                    <a:lnB w="6350" cap="flat" cmpd="sng" algn="ctr">
+                      <a:solidFill>
+                        <a:srgbClr val="D6DEE7"/>
+                      </a:solidFill>
+                      <a:prstDash val="solid"/>
+                      <a:round/>
+                      <a:headEnd type="none" w="med" len="med"/>
+                      <a:tailEnd type="none" w="med" len="med"/>
+                    </a:lnB>
+                    <a:solidFill>
+                      <a:srgbClr val="FFFFFF"/>
+                    </a:solidFill>
+                  </a:tcPr>
+                </a:tc>
+                <a:tc>
+                  <a:txBody>
+                    <a:bodyPr/>
+                    <a:lstStyle/>
+                    <a:p>
+                      <a:pPr marL="0" indent="0" algn="l">
+                        <a:buNone/>
+                      </a:pPr>
+                      <a:r>
+                        <a:rPr lang="en-US" sz="1100" dirty="0">
+                          <a:solidFill>
+                            <a:srgbClr val="16202E"/>
+                          </a:solidFill>
+                          <a:latin typeface="Calibri" pitchFamily="34" charset="0"/>
+                          <a:ea typeface="Calibri" pitchFamily="34" charset="-122"/>
+                          <a:cs typeface="Calibri" pitchFamily="34" charset="-120"/>
+                        </a:rPr>
+                        <a:t>5.5%</a:t>
+                      </a:r>
+                      <a:endParaRPr lang="en-US" sz="1100" dirty="0"/>
+                    </a:p>
+                  </a:txBody>
+                  <a:tcPr marL="101600" marR="101600" marT="50800" marB="50800" anchor="ctr">
+                    <a:lnL w="6350" cap="flat" cmpd="sng" algn="ctr">
+                      <a:solidFill>
+                        <a:srgbClr val="D6DEE7"/>
+                      </a:solidFill>
+                      <a:prstDash val="solid"/>
+                      <a:round/>
+                      <a:headEnd type="none" w="med" len="med"/>
+                      <a:tailEnd type="none" w="med" len="med"/>
+                    </a:lnL>
+                    <a:lnR w="6350" cap="flat" cmpd="sng" algn="ctr">
+                      <a:solidFill>
+                        <a:srgbClr val="D6DEE7"/>
+                      </a:solidFill>
+                      <a:prstDash val="solid"/>
+                      <a:round/>
+                      <a:headEnd type="none" w="med" len="med"/>
+                      <a:tailEnd type="none" w="med" len="med"/>
+                    </a:lnR>
+                    <a:lnT w="6350" cap="flat" cmpd="sng" algn="ctr">
+                      <a:solidFill>
+                        <a:srgbClr val="D6DEE7"/>
+                      </a:solidFill>
+                      <a:prstDash val="solid"/>
+                      <a:round/>
+                      <a:headEnd type="none" w="med" len="med"/>
+                      <a:tailEnd type="none" w="med" len="med"/>
+                    </a:lnT>
+                    <a:lnB w="6350" cap="flat" cmpd="sng" algn="ctr">
+                      <a:solidFill>
+                        <a:srgbClr val="D6DEE7"/>
+                      </a:solidFill>
+                      <a:prstDash val="solid"/>
+                      <a:round/>
+                      <a:headEnd type="none" w="med" len="med"/>
+                      <a:tailEnd type="none" w="med" len="med"/>
+                    </a:lnB>
+                    <a:solidFill>
+                      <a:srgbClr val="FFFFFF"/>
+                    </a:solidFill>
+                  </a:tcPr>
+                </a:tc>
+                <a:tc>
+                  <a:txBody>
+                    <a:bodyPr/>
+                    <a:lstStyle/>
+                    <a:p>
+                      <a:pPr marL="0" indent="0" algn="l">
+                        <a:buNone/>
+                      </a:pPr>
+                      <a:r>
+                        <a:rPr lang="en-US" sz="1100" dirty="0">
+                          <a:solidFill>
+                            <a:srgbClr val="16202E"/>
+                          </a:solidFill>
+                          <a:latin typeface="Calibri" pitchFamily="34" charset="0"/>
+                          <a:ea typeface="Calibri" pitchFamily="34" charset="-122"/>
+                          <a:cs typeface="Calibri" pitchFamily="34" charset="-120"/>
+                        </a:rPr>
+                        <a:t>22.3%</a:t>
+                      </a:r>
+                      <a:endParaRPr lang="en-US" sz="1100" dirty="0"/>
+                    </a:p>
+                  </a:txBody>
+                  <a:tcPr marL="101600" marR="101600" marT="50800" marB="50800" anchor="ctr">
+                    <a:lnL w="6350" cap="flat" cmpd="sng" algn="ctr">
+                      <a:solidFill>
+                        <a:srgbClr val="D6DEE7"/>
+                      </a:solidFill>
+                      <a:prstDash val="solid"/>
+                      <a:round/>
+                      <a:headEnd type="none" w="med" len="med"/>
+                      <a:tailEnd type="none" w="med" len="med"/>
+                    </a:lnL>
+                    <a:lnR w="6350" cap="flat" cmpd="sng" algn="ctr">
+                      <a:solidFill>
+                        <a:srgbClr val="D6DEE7"/>
+                      </a:solidFill>
+                      <a:prstDash val="solid"/>
+                      <a:round/>
+                      <a:headEnd type="none" w="med" len="med"/>
+                      <a:tailEnd type="none" w="med" len="med"/>
+                    </a:lnR>
+                    <a:lnT w="6350" cap="flat" cmpd="sng" algn="ctr">
+                      <a:solidFill>
+                        <a:srgbClr val="D6DEE7"/>
+                      </a:solidFill>
+                      <a:prstDash val="solid"/>
+                      <a:round/>
+                      <a:headEnd type="none" w="med" len="med"/>
+                      <a:tailEnd type="none" w="med" len="med"/>
+                    </a:lnT>
+                    <a:lnB w="6350" cap="flat" cmpd="sng" algn="ctr">
+                      <a:solidFill>
+                        <a:srgbClr val="D6DEE7"/>
+                      </a:solidFill>
+                      <a:prstDash val="solid"/>
+                      <a:round/>
+                      <a:headEnd type="none" w="med" len="med"/>
+                      <a:tailEnd type="none" w="med" len="med"/>
+                    </a:lnB>
+                    <a:solidFill>
+                      <a:srgbClr val="FFFFFF"/>
+                    </a:solidFill>
+                  </a:tcPr>
+                </a:tc>
+                <a:extLst>
+                  <a:ext uri="{0D108BD9-81ED-4DB2-BD59-A6C34878D82A}">
+                    <a16:rowId xmlns:a16="http://schemas.microsoft.com/office/drawing/2014/main" val="10001"/>
+                  </a:ext>
+                </a:extLst>
+              </a:tr>
+              <a:tr h="320000">
+                <a:tc>
+                  <a:txBody>
+                    <a:bodyPr/>
+                    <a:lstStyle/>
+                    <a:p>
+                      <a:pPr marL="0" indent="0" algn="l">
+                        <a:buNone/>
+                      </a:pPr>
+                      <a:r>
+                        <a:rPr lang="en-US" sz="1100" b="1" dirty="0">
+                          <a:solidFill>
+                            <a:srgbClr val="16202E"/>
+                          </a:solidFill>
+                          <a:latin typeface="Calibri" pitchFamily="34" charset="0"/>
+                          <a:ea typeface="Calibri" pitchFamily="34" charset="-122"/>
+                          <a:cs typeface="Calibri" pitchFamily="34" charset="-120"/>
+                        </a:rPr>
+                        <a:t>Opus 4.8</a:t>
+                      </a:r>
+                      <a:endParaRPr lang="en-US" sz="1100" dirty="0"/>
+                    </a:p>
+                  </a:txBody>
+                  <a:tcPr marL="101600" marR="101600" marT="50800" marB="50800" anchor="ctr">
+                    <a:lnL w="6350" cap="flat" cmpd="sng" algn="ctr">
+                      <a:solidFill>
+                        <a:srgbClr val="D6DEE7"/>
+                      </a:solidFill>
+                      <a:prstDash val="solid"/>
+                      <a:round/>
+                      <a:headEnd type="none" w="med" len="med"/>
+                      <a:tailEnd type="none" w="med" len="med"/>
+                    </a:lnL>
+                    <a:lnR w="6350" cap="flat" cmpd="sng" algn="ctr">
+                      <a:solidFill>
+                        <a:srgbClr val="D6DEE7"/>
+                      </a:solidFill>
+                      <a:prstDash val="solid"/>
+                      <a:round/>
+                      <a:headEnd type="none" w="med" len="med"/>
+                      <a:tailEnd type="none" w="med" len="med"/>
+                    </a:lnR>
+                    <a:lnT w="6350" cap="flat" cmpd="sng" algn="ctr">
+                      <a:solidFill>
+                        <a:srgbClr val="D6DEE7"/>
+                      </a:solidFill>
+                      <a:prstDash val="solid"/>
+                      <a:round/>
+                      <a:headEnd type="none" w="med" len="med"/>
+                      <a:tailEnd type="none" w="med" len="med"/>
+                    </a:lnT>
+                    <a:lnB w="6350" cap="flat" cmpd="sng" algn="ctr">
+                      <a:solidFill>
+                        <a:srgbClr val="D6DEE7"/>
+                      </a:solidFill>
+                      <a:prstDash val="solid"/>
+                      <a:round/>
+                      <a:headEnd type="none" w="med" len="med"/>
+                      <a:tailEnd type="none" w="med" len="med"/>
+                    </a:lnB>
+                    <a:solidFill>
+                      <a:srgbClr val="F4F6F9"/>
+                    </a:solidFill>
+                  </a:tcPr>
+                </a:tc>
+                <a:tc>
+                  <a:txBody>
+                    <a:bodyPr/>
+                    <a:lstStyle/>
+                    <a:p>
+                      <a:pPr marL="0" indent="0" algn="l">
+                        <a:buNone/>
+                      </a:pPr>
+                      <a:r>
+                        <a:rPr lang="en-US" sz="1100" dirty="0">
+                          <a:solidFill>
+                            <a:srgbClr val="16202E"/>
+                          </a:solidFill>
+                          <a:latin typeface="Calibri" pitchFamily="34" charset="0"/>
+                          <a:ea typeface="Calibri" pitchFamily="34" charset="-122"/>
+                          <a:cs typeface="Calibri" pitchFamily="34" charset="-120"/>
+                        </a:rPr>
+                        <a:t>14.7%</a:t>
+                      </a:r>
+                      <a:endParaRPr lang="en-US" sz="1100" dirty="0"/>
+                    </a:p>
+                  </a:txBody>
+                  <a:tcPr marL="101600" marR="101600" marT="50800" marB="50800" anchor="ctr">
+                    <a:lnL w="6350" cap="flat" cmpd="sng" algn="ctr">
+                      <a:solidFill>
+                        <a:srgbClr val="D6DEE7"/>
+                      </a:solidFill>
+                      <a:prstDash val="solid"/>
+                      <a:round/>
+                      <a:headEnd type="none" w="med" len="med"/>
+                      <a:tailEnd type="none" w="med" len="med"/>
+                    </a:lnL>
+                    <a:lnR w="6350" cap="flat" cmpd="sng" algn="ctr">
+                      <a:solidFill>
+                        <a:srgbClr val="D6DEE7"/>
+                      </a:solidFill>
+                      <a:prstDash val="solid"/>
+                      <a:round/>
+                      <a:headEnd type="none" w="med" len="med"/>
+                      <a:tailEnd type="none" w="med" len="med"/>
+                    </a:lnR>
+                    <a:lnT w="6350" cap="flat" cmpd="sng" algn="ctr">
+                      <a:solidFill>
+                        <a:srgbClr val="D6DEE7"/>
+                      </a:solidFill>
+                      <a:prstDash val="solid"/>
+                      <a:round/>
+                      <a:headEnd type="none" w="med" len="med"/>
+                      <a:tailEnd type="none" w="med" len="med"/>
+                    </a:lnT>
+                    <a:lnB w="6350" cap="flat" cmpd="sng" algn="ctr">
+                      <a:solidFill>
+                        <a:srgbClr val="D6DEE7"/>
+                      </a:solidFill>
+                      <a:prstDash val="solid"/>
+                      <a:round/>
+                      <a:headEnd type="none" w="med" len="med"/>
+                      <a:tailEnd type="none" w="med" len="med"/>
+                    </a:lnB>
+                    <a:solidFill>
+                      <a:srgbClr val="F4F6F9"/>
+                    </a:solidFill>
+                  </a:tcPr>
+                </a:tc>
+                <a:tc>
+                  <a:txBody>
+                    <a:bodyPr/>
+                    <a:lstStyle/>
+                    <a:p>
+                      <a:pPr marL="0" indent="0" algn="l">
+                        <a:buNone/>
+                      </a:pPr>
+                      <a:r>
+                        <a:rPr lang="en-US" sz="1100" dirty="0">
+                          <a:solidFill>
+                            <a:srgbClr val="16202E"/>
+                          </a:solidFill>
+                          <a:latin typeface="Calibri" pitchFamily="34" charset="0"/>
+                          <a:ea typeface="Calibri" pitchFamily="34" charset="-122"/>
+                          <a:cs typeface="Calibri" pitchFamily="34" charset="-120"/>
+                        </a:rPr>
+                        <a:t>37.4%</a:t>
+                      </a:r>
+                      <a:endParaRPr lang="en-US" sz="1100" dirty="0"/>
+                    </a:p>
+                  </a:txBody>
+                  <a:tcPr marL="101600" marR="101600" marT="50800" marB="50800" anchor="ctr">
+                    <a:lnL w="6350" cap="flat" cmpd="sng" algn="ctr">
+                      <a:solidFill>
+                        <a:srgbClr val="D6DEE7"/>
+                      </a:solidFill>
+                      <a:prstDash val="solid"/>
+                      <a:round/>
+                      <a:headEnd type="none" w="med" len="med"/>
+                      <a:tailEnd type="none" w="med" len="med"/>
+                    </a:lnL>
+                    <a:lnR w="6350" cap="flat" cmpd="sng" algn="ctr">
+                      <a:solidFill>
+                        <a:srgbClr val="D6DEE7"/>
+                      </a:solidFill>
+                      <a:prstDash val="solid"/>
+                      <a:round/>
+                      <a:headEnd type="none" w="med" len="med"/>
+                      <a:tailEnd type="none" w="med" len="med"/>
+                    </a:lnR>
+                    <a:lnT w="6350" cap="flat" cmpd="sng" algn="ctr">
+                      <a:solidFill>
+                        <a:srgbClr val="D6DEE7"/>
+                      </a:solidFill>
+                      <a:prstDash val="solid"/>
+                      <a:round/>
+                      <a:headEnd type="none" w="med" len="med"/>
+                      <a:tailEnd type="none" w="med" len="med"/>
+                    </a:lnT>
+                    <a:lnB w="6350" cap="flat" cmpd="sng" algn="ctr">
+                      <a:solidFill>
+                        <a:srgbClr val="D6DEE7"/>
+                      </a:solidFill>
+                      <a:prstDash val="solid"/>
+                      <a:round/>
+                      <a:headEnd type="none" w="med" len="med"/>
+                      <a:tailEnd type="none" w="med" len="med"/>
+                    </a:lnB>
+                    <a:solidFill>
+                      <a:srgbClr val="F4F6F9"/>
+                    </a:solidFill>
+                  </a:tcPr>
+                </a:tc>
+                <a:extLst>
+                  <a:ext uri="{0D108BD9-81ED-4DB2-BD59-A6C34878D82A}">
+                    <a16:rowId xmlns:a16="http://schemas.microsoft.com/office/drawing/2014/main" val="10002"/>
+                  </a:ext>
+                </a:extLst>
+              </a:tr>
+              <a:tr h="320000">
+                <a:tc>
+                  <a:txBody>
+                    <a:bodyPr/>
+                    <a:lstStyle/>
+                    <a:p>
+                      <a:pPr marL="0" indent="0" algn="l">
+                        <a:buNone/>
+                      </a:pPr>
+                      <a:r>
+                        <a:rPr lang="en-US" sz="1100" b="1" dirty="0">
+                          <a:solidFill>
+                            <a:srgbClr val="16202E"/>
+                          </a:solidFill>
+                          <a:latin typeface="Calibri" pitchFamily="34" charset="0"/>
+                          <a:ea typeface="Calibri" pitchFamily="34" charset="-122"/>
+                          <a:cs typeface="Calibri" pitchFamily="34" charset="-120"/>
+                        </a:rPr>
+                        <a:t>DeepSeek R1</a:t>
+                      </a:r>
+                      <a:endParaRPr lang="en-US" sz="1100" dirty="0"/>
+                    </a:p>
+                  </a:txBody>
+                  <a:tcPr marL="101600" marR="101600" marT="50800" marB="50800" anchor="ctr">
+                    <a:lnL w="6350" cap="flat" cmpd="sng" algn="ctr">
+                      <a:solidFill>
+                        <a:srgbClr val="D6DEE7"/>
+                      </a:solidFill>
+                      <a:prstDash val="solid"/>
+                      <a:round/>
+                      <a:headEnd type="none" w="med" len="med"/>
+                      <a:tailEnd type="none" w="med" len="med"/>
+                    </a:lnL>
+                    <a:lnR w="6350" cap="flat" cmpd="sng" algn="ctr">
+                      <a:solidFill>
+                        <a:srgbClr val="D6DEE7"/>
+                      </a:solidFill>
+                      <a:prstDash val="solid"/>
+                      <a:round/>
+                      <a:headEnd type="none" w="med" len="med"/>
+                      <a:tailEnd type="none" w="med" len="med"/>
+                    </a:lnR>
+                    <a:lnT w="6350" cap="flat" cmpd="sng" algn="ctr">
+                      <a:solidFill>
+                        <a:srgbClr val="D6DEE7"/>
+                      </a:solidFill>
+                      <a:prstDash val="solid"/>
+                      <a:round/>
+                      <a:headEnd type="none" w="med" len="med"/>
+                      <a:tailEnd type="none" w="med" len="med"/>
+                    </a:lnT>
+                    <a:lnB w="6350" cap="flat" cmpd="sng" algn="ctr">
+                      <a:solidFill>
+                        <a:srgbClr val="D6DEE7"/>
+                      </a:solidFill>
+                      <a:prstDash val="solid"/>
+                      <a:round/>
+                      <a:headEnd type="none" w="med" len="med"/>
+                      <a:tailEnd type="none" w="med" len="med"/>
+                    </a:lnB>
+                    <a:solidFill>
+                      <a:srgbClr val="FFFFFF"/>
+                    </a:solidFill>
+                  </a:tcPr>
+                </a:tc>
+                <a:tc>
+                  <a:txBody>
+                    <a:bodyPr/>
+                    <a:lstStyle/>
+                    <a:p>
+                      <a:pPr marL="0" indent="0" algn="l">
+                        <a:buNone/>
+                      </a:pPr>
+                      <a:r>
+                        <a:rPr lang="en-US" sz="1100" dirty="0">
+                          <a:solidFill>
+                            <a:srgbClr val="16202E"/>
+                          </a:solidFill>
+                          <a:latin typeface="Calibri" pitchFamily="34" charset="0"/>
+                          <a:ea typeface="Calibri" pitchFamily="34" charset="-122"/>
+                          <a:cs typeface="Calibri" pitchFamily="34" charset="-120"/>
+                        </a:rPr>
+                        <a:t>21.8%</a:t>
+                      </a:r>
+                      <a:endParaRPr lang="en-US" sz="1100" dirty="0"/>
+                    </a:p>
+                  </a:txBody>
+                  <a:tcPr marL="101600" marR="101600" marT="50800" marB="50800" anchor="ctr">
+                    <a:lnL w="6350" cap="flat" cmpd="sng" algn="ctr">
+                      <a:solidFill>
+                        <a:srgbClr val="D6DEE7"/>
+                      </a:solidFill>
+                      <a:prstDash val="solid"/>
+                      <a:round/>
+                      <a:headEnd type="none" w="med" len="med"/>
+                      <a:tailEnd type="none" w="med" len="med"/>
+                    </a:lnL>
+                    <a:lnR w="6350" cap="flat" cmpd="sng" algn="ctr">
+                      <a:solidFill>
+                        <a:srgbClr val="D6DEE7"/>
+                      </a:solidFill>
+                      <a:prstDash val="solid"/>
+                      <a:round/>
+                      <a:headEnd type="none" w="med" len="med"/>
+                      <a:tailEnd type="none" w="med" len="med"/>
+                    </a:lnR>
+                    <a:lnT w="6350" cap="flat" cmpd="sng" algn="ctr">
+                      <a:solidFill>
+                        <a:srgbClr val="D6DEE7"/>
+                      </a:solidFill>
+                      <a:prstDash val="solid"/>
+                      <a:round/>
+                      <a:headEnd type="none" w="med" len="med"/>
+                      <a:tailEnd type="none" w="med" len="med"/>
+                    </a:lnT>
+                    <a:lnB w="6350" cap="flat" cmpd="sng" algn="ctr">
+                      <a:solidFill>
+                        <a:srgbClr val="D6DEE7"/>
+                      </a:solidFill>
+                      <a:prstDash val="solid"/>
+                      <a:round/>
+                      <a:headEnd type="none" w="med" len="med"/>
+                      <a:tailEnd type="none" w="med" len="med"/>
+                    </a:lnB>
+                    <a:solidFill>
+                      <a:srgbClr val="FFFFFF"/>
+                    </a:solidFill>
+                  </a:tcPr>
+                </a:tc>
+                <a:tc>
+                  <a:txBody>
+                    <a:bodyPr/>
+                    <a:lstStyle/>
+                    <a:p>
+                      <a:pPr marL="0" indent="0" algn="l">
+                        <a:buNone/>
+                      </a:pPr>
+                      <a:r>
+                        <a:rPr lang="en-US" sz="1100" dirty="0">
+                          <a:solidFill>
+                            <a:srgbClr val="16202E"/>
+                          </a:solidFill>
+                          <a:latin typeface="Calibri" pitchFamily="34" charset="0"/>
+                          <a:ea typeface="Calibri" pitchFamily="34" charset="-122"/>
+                          <a:cs typeface="Calibri" pitchFamily="34" charset="-120"/>
+                        </a:rPr>
+                        <a:t>20.6%</a:t>
+                      </a:r>
+                      <a:endParaRPr lang="en-US" sz="1100" dirty="0"/>
+                    </a:p>
+                  </a:txBody>
+                  <a:tcPr marL="101600" marR="101600" marT="50800" marB="50800" anchor="ctr">
+                    <a:lnL w="6350" cap="flat" cmpd="sng" algn="ctr">
+                      <a:solidFill>
+                        <a:srgbClr val="D6DEE7"/>
+                      </a:solidFill>
+                      <a:prstDash val="solid"/>
+                      <a:round/>
+                      <a:headEnd type="none" w="med" len="med"/>
+                      <a:tailEnd type="none" w="med" len="med"/>
+                    </a:lnL>
+                    <a:lnR w="6350" cap="flat" cmpd="sng" algn="ctr">
+                      <a:solidFill>
+                        <a:srgbClr val="D6DEE7"/>
+                      </a:solidFill>
+                      <a:prstDash val="solid"/>
+                      <a:round/>
+                      <a:headEnd type="none" w="med" len="med"/>
+                      <a:tailEnd type="none" w="med" len="med"/>
+                    </a:lnR>
+                    <a:lnT w="6350" cap="flat" cmpd="sng" algn="ctr">
+                      <a:solidFill>
+                        <a:srgbClr val="D6DEE7"/>
+                      </a:solidFill>
+                      <a:prstDash val="solid"/>
+                      <a:round/>
+                      <a:headEnd type="none" w="med" len="med"/>
+                      <a:tailEnd type="none" w="med" len="med"/>
+                    </a:lnT>
+                    <a:lnB w="6350" cap="flat" cmpd="sng" algn="ctr">
+                      <a:solidFill>
+                        <a:srgbClr val="D6DEE7"/>
+                      </a:solidFill>
+                      <a:prstDash val="solid"/>
+                      <a:round/>
+                      <a:headEnd type="none" w="med" len="med"/>
+                      <a:tailEnd type="none" w="med" len="med"/>
+                    </a:lnB>
+                    <a:solidFill>
+                      <a:srgbClr val="FFFFFF"/>
+                    </a:solidFill>
+                  </a:tcPr>
+                </a:tc>
+                <a:extLst>
+                  <a:ext uri="{0D108BD9-81ED-4DB2-BD59-A6C34878D82A}">
+                    <a16:rowId xmlns:a16="http://schemas.microsoft.com/office/drawing/2014/main" val="10003"/>
+                  </a:ext>
+                </a:extLst>
+              </a:tr>
+            </a:tbl>
+          </a:graphicData>
+        </a:graphic>
+      </p:graphicFrame>
+      <p:sp>
+        <p:nvSpPr>
+          <p:cNvPr id="10" name="TextBox 9"/>
+          <p:cNvSpPr txBox="1"/>
+          <p:nvPr/>
+        </p:nvSpPr>
+        <p:spPr>
+          <a:xfrm>
+            <a:off x="640080" y="3970000"/>
+            <a:ext cx="10911535" cy="274320"/>
+          </a:xfrm>
+          <a:prstGeom prst="rect">
+            <a:avLst/>
+          </a:prstGeom>
+          <a:noFill/>
+        </p:spPr>
+        <p:txBody>
+          <a:bodyPr wrap="square" anchor="t">
+            <a:spAutoFit/>
+          </a:bodyPr>
+          <a:lstStyle/>
+          <a:p>
+            <a:pPr algn="l">
+              <a:spcAft>
+                <a:spcPts val="400"/>
+              </a:spcAft>
+            </a:pPr>
+            <a:r>
+              <a:rPr sz="1200" b="1">
+                <a:solidFill>
+                  <a:srgbClr val="0D9488"/>
+                </a:solidFill>
+                <a:latin typeface="Calibri"/>
+              </a:rPr>
+              <a:t>PAIRWISE AGREEMENT   ·   exact match / quadratic-weighted Cohen's κ</a:t>
+            </a:r>
+          </a:p>
+        </p:txBody>
+      </p:sp>
+      <p:graphicFrame>
+        <p:nvGraphicFramePr>
+          <p:cNvPr id="11" name="Table 10"/>
+          <p:cNvGraphicFramePr>
+            <a:graphicFrameLocks noGrp="1"/>
+          </p:cNvGraphicFramePr>
+          <p:nvPr/>
+        </p:nvGraphicFramePr>
+        <p:xfrm>
+          <a:off x="640080" y="4290000"/>
+          <a:ext cx="11155680" cy="1280000"/>
+        </p:xfrm>
+        <a:graphic>
+          <a:graphicData uri="http://schemas.openxmlformats.org/drawingml/2006/table">
+            <a:tbl>
+              <a:tblPr/>
+              <a:tblGrid>
+                <a:gridCol w="3718560">
+                  <a:extLst>
+                    <a:ext uri="{9D8B030D-6E8A-4147-A177-3AD203B41FA5}">
+                      <a16:colId xmlns:a16="http://schemas.microsoft.com/office/drawing/2014/main" val="20000"/>
+                    </a:ext>
+                  </a:extLst>
+                </a:gridCol>
+                <a:gridCol w="3718560">
+                  <a:extLst>
+                    <a:ext uri="{9D8B030D-6E8A-4147-A177-3AD203B41FA5}">
+                      <a16:colId xmlns:a16="http://schemas.microsoft.com/office/drawing/2014/main" val="20001"/>
+                    </a:ext>
+                  </a:extLst>
+                </a:gridCol>
+                <a:gridCol w="3718560">
+                  <a:extLst>
+                    <a:ext uri="{9D8B030D-6E8A-4147-A177-3AD203B41FA5}">
+                      <a16:colId xmlns:a16="http://schemas.microsoft.com/office/drawing/2014/main" val="20002"/>
+                    </a:ext>
+                  </a:extLst>
+                </a:gridCol>
+              </a:tblGrid>
+              <a:tr h="320000">
+                <a:tc>
+                  <a:txBody>
+                    <a:bodyPr/>
+                    <a:lstStyle/>
+                    <a:p>
+                      <a:pPr marL="0" indent="0" algn="l">
+                        <a:buNone/>
+                      </a:pPr>
+                      <a:r>
+                        <a:rPr lang="en-US" sz="1100" b="1" dirty="0">
+                          <a:solidFill>
+                            <a:srgbClr val="EAF0F7"/>
+                          </a:solidFill>
+                          <a:latin typeface="Calibri" pitchFamily="34" charset="0"/>
+                          <a:ea typeface="Calibri" pitchFamily="34" charset="-122"/>
+                          <a:cs typeface="Calibri" pitchFamily="34" charset="-120"/>
+                        </a:rPr>
+                        <a:t>Judge pair</a:t>
+                      </a:r>
+                      <a:endParaRPr lang="en-US" sz="1100" dirty="0"/>
+                    </a:p>
+                  </a:txBody>
+                  <a:tcPr marL="101600" marR="101600" marT="50800" marB="50800" anchor="ctr">
+                    <a:lnL w="6350" cap="flat" cmpd="sng" algn="ctr">
+                      <a:solidFill>
+                        <a:srgbClr val="D6DEE7"/>
+                      </a:solidFill>
+                      <a:prstDash val="solid"/>
+                      <a:round/>
+                      <a:headEnd type="none" w="med" len="med"/>
+                      <a:tailEnd type="none" w="med" len="med"/>
+                    </a:lnL>
+                    <a:lnR w="6350" cap="flat" cmpd="sng" algn="ctr">
+                      <a:solidFill>
+                        <a:srgbClr val="D6DEE7"/>
+                      </a:solidFill>
+                      <a:prstDash val="solid"/>
+                      <a:round/>
+                      <a:headEnd type="none" w="med" len="med"/>
+                      <a:tailEnd type="none" w="med" len="med"/>
+                    </a:lnR>
+                    <a:lnT w="6350" cap="flat" cmpd="sng" algn="ctr">
+                      <a:solidFill>
+                        <a:srgbClr val="D6DEE7"/>
+                      </a:solidFill>
+                      <a:prstDash val="solid"/>
+                      <a:round/>
+                      <a:headEnd type="none" w="med" len="med"/>
+                      <a:tailEnd type="none" w="med" len="med"/>
+                    </a:lnT>
+                    <a:lnB w="6350" cap="flat" cmpd="sng" algn="ctr">
+                      <a:solidFill>
+                        <a:srgbClr val="D6DEE7"/>
+                      </a:solidFill>
+                      <a:prstDash val="solid"/>
+                      <a:round/>
+                      <a:headEnd type="none" w="med" len="med"/>
+                      <a:tailEnd type="none" w="med" len="med"/>
+                    </a:lnB>
+                    <a:solidFill>
+                      <a:srgbClr val="1E2A3A"/>
+                    </a:solidFill>
+                  </a:tcPr>
+                </a:tc>
+                <a:tc>
+                  <a:txBody>
+                    <a:bodyPr/>
+                    <a:lstStyle/>
+                    <a:p>
+                      <a:pPr marL="0" indent="0" algn="l">
+                        <a:buNone/>
+                      </a:pPr>
+                      <a:r>
+                        <a:rPr lang="en-US" sz="1100" b="1" dirty="0">
+                          <a:solidFill>
+                            <a:srgbClr val="EAF0F7"/>
+                          </a:solidFill>
+                          <a:latin typeface="Calibri" pitchFamily="34" charset="0"/>
+                          <a:ea typeface="Calibri" pitchFamily="34" charset="-122"/>
+                          <a:cs typeface="Calibri" pitchFamily="34" charset="-120"/>
+                        </a:rPr>
+                        <a:t>Relevance  (exact / κ)</a:t>
+                      </a:r>
+                      <a:endParaRPr lang="en-US" sz="1100" dirty="0"/>
+                    </a:p>
+                  </a:txBody>
+                  <a:tcPr marL="101600" marR="101600" marT="50800" marB="50800" anchor="ctr">
+                    <a:lnL w="6350" cap="flat" cmpd="sng" algn="ctr">
+                      <a:solidFill>
+                        <a:srgbClr val="D6DEE7"/>
+                      </a:solidFill>
+                      <a:prstDash val="solid"/>
+                      <a:round/>
+                      <a:headEnd type="none" w="med" len="med"/>
+                      <a:tailEnd type="none" w="med" len="med"/>
+                    </a:lnL>
+                    <a:lnR w="6350" cap="flat" cmpd="sng" algn="ctr">
+                      <a:solidFill>
+                        <a:srgbClr val="D6DEE7"/>
+                      </a:solidFill>
+                      <a:prstDash val="solid"/>
+                      <a:round/>
+                      <a:headEnd type="none" w="med" len="med"/>
+                      <a:tailEnd type="none" w="med" len="med"/>
+                    </a:lnR>
+                    <a:lnT w="6350" cap="flat" cmpd="sng" algn="ctr">
+                      <a:solidFill>
+                        <a:srgbClr val="D6DEE7"/>
+                      </a:solidFill>
+                      <a:prstDash val="solid"/>
+                      <a:round/>
+                      <a:headEnd type="none" w="med" len="med"/>
+                      <a:tailEnd type="none" w="med" len="med"/>
+                    </a:lnT>
+                    <a:lnB w="6350" cap="flat" cmpd="sng" algn="ctr">
+                      <a:solidFill>
+                        <a:srgbClr val="D6DEE7"/>
+                      </a:solidFill>
+                      <a:prstDash val="solid"/>
+                      <a:round/>
+                      <a:headEnd type="none" w="med" len="med"/>
+                      <a:tailEnd type="none" w="med" len="med"/>
+                    </a:lnB>
+                    <a:solidFill>
+                      <a:srgbClr val="1E2A3A"/>
+                    </a:solidFill>
+                  </a:tcPr>
+                </a:tc>
+                <a:tc>
+                  <a:txBody>
+                    <a:bodyPr/>
+                    <a:lstStyle/>
+                    <a:p>
+                      <a:pPr marL="0" indent="0" algn="l">
+                        <a:buNone/>
+                      </a:pPr>
+                      <a:r>
+                        <a:rPr lang="en-US" sz="1100" b="1" dirty="0">
+                          <a:solidFill>
+                            <a:srgbClr val="EAF0F7"/>
+                          </a:solidFill>
+                          <a:latin typeface="Calibri" pitchFamily="34" charset="0"/>
+                          <a:ea typeface="Calibri" pitchFamily="34" charset="-122"/>
+                          <a:cs typeface="Calibri" pitchFamily="34" charset="-120"/>
+                        </a:rPr>
+                        <a:t>Quality  (exact / κ)</a:t>
+                      </a:r>
+                      <a:endParaRPr lang="en-US" sz="1100" dirty="0"/>
+                    </a:p>
+                  </a:txBody>
+                  <a:tcPr marL="101600" marR="101600" marT="50800" marB="50800" anchor="ctr">
+                    <a:lnL w="6350" cap="flat" cmpd="sng" algn="ctr">
+                      <a:solidFill>
+                        <a:srgbClr val="D6DEE7"/>
+                      </a:solidFill>
+                      <a:prstDash val="solid"/>
+                      <a:round/>
+                      <a:headEnd type="none" w="med" len="med"/>
+                      <a:tailEnd type="none" w="med" len="med"/>
+                    </a:lnL>
+                    <a:lnR w="6350" cap="flat" cmpd="sng" algn="ctr">
+                      <a:solidFill>
+                        <a:srgbClr val="D6DEE7"/>
+                      </a:solidFill>
+                      <a:prstDash val="solid"/>
+                      <a:round/>
+                      <a:headEnd type="none" w="med" len="med"/>
+                      <a:tailEnd type="none" w="med" len="med"/>
+                    </a:lnR>
+                    <a:lnT w="6350" cap="flat" cmpd="sng" algn="ctr">
+                      <a:solidFill>
+                        <a:srgbClr val="D6DEE7"/>
+                      </a:solidFill>
+                      <a:prstDash val="solid"/>
+                      <a:round/>
+                      <a:headEnd type="none" w="med" len="med"/>
+                      <a:tailEnd type="none" w="med" len="med"/>
+                    </a:lnT>
+                    <a:lnB w="6350" cap="flat" cmpd="sng" algn="ctr">
+                      <a:solidFill>
+                        <a:srgbClr val="D6DEE7"/>
+                      </a:solidFill>
+                      <a:prstDash val="solid"/>
+                      <a:round/>
+                      <a:headEnd type="none" w="med" len="med"/>
+                      <a:tailEnd type="none" w="med" len="med"/>
+                    </a:lnB>
+                    <a:solidFill>
+                      <a:srgbClr val="1E2A3A"/>
+                    </a:solidFill>
+                  </a:tcPr>
+                </a:tc>
+                <a:extLst>
+                  <a:ext uri="{0D108BD9-81ED-4DB2-BD59-A6C34878D82A}">
+                    <a16:rowId xmlns:a16="http://schemas.microsoft.com/office/drawing/2014/main" val="10000"/>
+                  </a:ext>
+                </a:extLst>
+              </a:tr>
+              <a:tr h="320000">
+                <a:tc>
+                  <a:txBody>
+                    <a:bodyPr/>
+                    <a:lstStyle/>
+                    <a:p>
+                      <a:pPr marL="0" indent="0" algn="l">
+                        <a:buNone/>
+                      </a:pPr>
+                      <a:r>
+                        <a:rPr lang="en-US" sz="1100" b="1" dirty="0">
+                          <a:solidFill>
+                            <a:srgbClr val="16202E"/>
+                          </a:solidFill>
+                          <a:latin typeface="Calibri" pitchFamily="34" charset="0"/>
+                          <a:ea typeface="Calibri" pitchFamily="34" charset="-122"/>
+                          <a:cs typeface="Calibri" pitchFamily="34" charset="-120"/>
+                        </a:rPr>
+                        <a:t>GPT-OSS 120B ↔ Opus 4.8</a:t>
+                      </a:r>
+                      <a:endParaRPr lang="en-US" sz="1100" dirty="0"/>
+                    </a:p>
+                  </a:txBody>
+                  <a:tcPr marL="101600" marR="101600" marT="50800" marB="50800" anchor="ctr">
+                    <a:lnL w="6350" cap="flat" cmpd="sng" algn="ctr">
+                      <a:solidFill>
+                        <a:srgbClr val="D6DEE7"/>
+                      </a:solidFill>
+                      <a:prstDash val="solid"/>
+                      <a:round/>
+                      <a:headEnd type="none" w="med" len="med"/>
+                      <a:tailEnd type="none" w="med" len="med"/>
+                    </a:lnL>
+                    <a:lnR w="6350" cap="flat" cmpd="sng" algn="ctr">
+                      <a:solidFill>
+                        <a:srgbClr val="D6DEE7"/>
+                      </a:solidFill>
+                      <a:prstDash val="solid"/>
+                      <a:round/>
+                      <a:headEnd type="none" w="med" len="med"/>
+                      <a:tailEnd type="none" w="med" len="med"/>
+                    </a:lnR>
+                    <a:lnT w="6350" cap="flat" cmpd="sng" algn="ctr">
+                      <a:solidFill>
+                        <a:srgbClr val="D6DEE7"/>
+                      </a:solidFill>
+                      <a:prstDash val="solid"/>
+                      <a:round/>
+                      <a:headEnd type="none" w="med" len="med"/>
+                      <a:tailEnd type="none" w="med" len="med"/>
+                    </a:lnT>
+                    <a:lnB w="6350" cap="flat" cmpd="sng" algn="ctr">
+                      <a:solidFill>
+                        <a:srgbClr val="D6DEE7"/>
+                      </a:solidFill>
+                      <a:prstDash val="solid"/>
+                      <a:round/>
+                      <a:headEnd type="none" w="med" len="med"/>
+                      <a:tailEnd type="none" w="med" len="med"/>
+                    </a:lnB>
+                    <a:solidFill>
+                      <a:srgbClr val="FFFFFF"/>
+                    </a:solidFill>
+                  </a:tcPr>
+                </a:tc>
+                <a:tc>
+                  <a:txBody>
+                    <a:bodyPr/>
+                    <a:lstStyle/>
+                    <a:p>
+                      <a:pPr marL="0" indent="0" algn="l">
+                        <a:buNone/>
+                      </a:pPr>
+                      <a:r>
+                        <a:rPr lang="en-US" sz="1100" dirty="0">
+                          <a:solidFill>
+                            <a:srgbClr val="16202E"/>
+                          </a:solidFill>
+                          <a:latin typeface="Calibri" pitchFamily="34" charset="0"/>
+                          <a:ea typeface="Calibri" pitchFamily="34" charset="-122"/>
+                          <a:cs typeface="Calibri" pitchFamily="34" charset="-120"/>
+                        </a:rPr>
+                        <a:t>79.8%  /  0.746</a:t>
+                      </a:r>
+                      <a:endParaRPr lang="en-US" sz="1100" dirty="0"/>
+                    </a:p>
+                  </a:txBody>
+                  <a:tcPr marL="101600" marR="101600" marT="50800" marB="50800" anchor="ctr">
+                    <a:lnL w="6350" cap="flat" cmpd="sng" algn="ctr">
+                      <a:solidFill>
+                        <a:srgbClr val="D6DEE7"/>
+                      </a:solidFill>
+                      <a:prstDash val="solid"/>
+                      <a:round/>
+                      <a:headEnd type="none" w="med" len="med"/>
+                      <a:tailEnd type="none" w="med" len="med"/>
+                    </a:lnL>
+                    <a:lnR w="6350" cap="flat" cmpd="sng" algn="ctr">
+                      <a:solidFill>
+                        <a:srgbClr val="D6DEE7"/>
+                      </a:solidFill>
+                      <a:prstDash val="solid"/>
+                      <a:round/>
+                      <a:headEnd type="none" w="med" len="med"/>
+                      <a:tailEnd type="none" w="med" len="med"/>
+                    </a:lnR>
+                    <a:lnT w="6350" cap="flat" cmpd="sng" algn="ctr">
+                      <a:solidFill>
+                        <a:srgbClr val="D6DEE7"/>
+                      </a:solidFill>
+                      <a:prstDash val="solid"/>
+                      <a:round/>
+                      <a:headEnd type="none" w="med" len="med"/>
+                      <a:tailEnd type="none" w="med" len="med"/>
+                    </a:lnT>
+                    <a:lnB w="6350" cap="flat" cmpd="sng" algn="ctr">
+                      <a:solidFill>
+                        <a:srgbClr val="D6DEE7"/>
+                      </a:solidFill>
+                      <a:prstDash val="solid"/>
+                      <a:round/>
+                      <a:headEnd type="none" w="med" len="med"/>
+                      <a:tailEnd type="none" w="med" len="med"/>
+                    </a:lnB>
+                    <a:solidFill>
+                      <a:srgbClr val="FFFFFF"/>
+                    </a:solidFill>
+                  </a:tcPr>
+                </a:tc>
+                <a:tc>
+                  <a:txBody>
+                    <a:bodyPr/>
+                    <a:lstStyle/>
+                    <a:p>
+                      <a:pPr marL="0" indent="0" algn="l">
+                        <a:buNone/>
+                      </a:pPr>
+                      <a:r>
+                        <a:rPr lang="en-US" sz="1100" dirty="0">
+                          <a:solidFill>
+                            <a:srgbClr val="16202E"/>
+                          </a:solidFill>
+                          <a:latin typeface="Calibri" pitchFamily="34" charset="0"/>
+                          <a:ea typeface="Calibri" pitchFamily="34" charset="-122"/>
+                          <a:cs typeface="Calibri" pitchFamily="34" charset="-120"/>
+                        </a:rPr>
+                        <a:t>40.3%  /  0.566</a:t>
+                      </a:r>
+                      <a:endParaRPr lang="en-US" sz="1100" dirty="0"/>
+                    </a:p>
+                  </a:txBody>
+                  <a:tcPr marL="101600" marR="101600" marT="50800" marB="50800" anchor="ctr">
+                    <a:lnL w="6350" cap="flat" cmpd="sng" algn="ctr">
+                      <a:solidFill>
+                        <a:srgbClr val="D6DEE7"/>
+                      </a:solidFill>
+                      <a:prstDash val="solid"/>
+                      <a:round/>
+                      <a:headEnd type="none" w="med" len="med"/>
+                      <a:tailEnd type="none" w="med" len="med"/>
+                    </a:lnL>
+                    <a:lnR w="6350" cap="flat" cmpd="sng" algn="ctr">
+                      <a:solidFill>
+                        <a:srgbClr val="D6DEE7"/>
+                      </a:solidFill>
+                      <a:prstDash val="solid"/>
+                      <a:round/>
+                      <a:headEnd type="none" w="med" len="med"/>
+                      <a:tailEnd type="none" w="med" len="med"/>
+                    </a:lnR>
+                    <a:lnT w="6350" cap="flat" cmpd="sng" algn="ctr">
+                      <a:solidFill>
+                        <a:srgbClr val="D6DEE7"/>
+                      </a:solidFill>
+                      <a:prstDash val="solid"/>
+                      <a:round/>
+                      <a:headEnd type="none" w="med" len="med"/>
+                      <a:tailEnd type="none" w="med" len="med"/>
+                    </a:lnT>
+                    <a:lnB w="6350" cap="flat" cmpd="sng" algn="ctr">
+                      <a:solidFill>
+                        <a:srgbClr val="D6DEE7"/>
+                      </a:solidFill>
+                      <a:prstDash val="solid"/>
+                      <a:round/>
+                      <a:headEnd type="none" w="med" len="med"/>
+                      <a:tailEnd type="none" w="med" len="med"/>
+                    </a:lnB>
+                    <a:solidFill>
+                      <a:srgbClr val="FFFFFF"/>
+                    </a:solidFill>
+                  </a:tcPr>
+                </a:tc>
+                <a:extLst>
+                  <a:ext uri="{0D108BD9-81ED-4DB2-BD59-A6C34878D82A}">
+                    <a16:rowId xmlns:a16="http://schemas.microsoft.com/office/drawing/2014/main" val="10001"/>
+                  </a:ext>
+                </a:extLst>
+              </a:tr>
+              <a:tr h="320000">
+                <a:tc>
+                  <a:txBody>
+                    <a:bodyPr/>
+                    <a:lstStyle/>
+                    <a:p>
+                      <a:pPr marL="0" indent="0" algn="l">
+                        <a:buNone/>
+                      </a:pPr>
+                      <a:r>
+                        <a:rPr lang="en-US" sz="1100" b="1" dirty="0">
+                          <a:solidFill>
+                            <a:srgbClr val="16202E"/>
+                          </a:solidFill>
+                          <a:latin typeface="Calibri" pitchFamily="34" charset="0"/>
+                          <a:ea typeface="Calibri" pitchFamily="34" charset="-122"/>
+                          <a:cs typeface="Calibri" pitchFamily="34" charset="-120"/>
+                        </a:rPr>
+                        <a:t>GPT-OSS 120B ↔ DeepSeek R1</a:t>
+                      </a:r>
+                      <a:endParaRPr lang="en-US" sz="1100" dirty="0"/>
+                    </a:p>
+                  </a:txBody>
+                  <a:tcPr marL="101600" marR="101600" marT="50800" marB="50800" anchor="ctr">
+                    <a:lnL w="6350" cap="flat" cmpd="sng" algn="ctr">
+                      <a:solidFill>
+                        <a:srgbClr val="D6DEE7"/>
+                      </a:solidFill>
+                      <a:prstDash val="solid"/>
+                      <a:round/>
+                      <a:headEnd type="none" w="med" len="med"/>
+                      <a:tailEnd type="none" w="med" len="med"/>
+                    </a:lnL>
+                    <a:lnR w="6350" cap="flat" cmpd="sng" algn="ctr">
+                      <a:solidFill>
+                        <a:srgbClr val="D6DEE7"/>
+                      </a:solidFill>
+                      <a:prstDash val="solid"/>
+                      <a:round/>
+                      <a:headEnd type="none" w="med" len="med"/>
+                      <a:tailEnd type="none" w="med" len="med"/>
+                    </a:lnR>
+                    <a:lnT w="6350" cap="flat" cmpd="sng" algn="ctr">
+                      <a:solidFill>
+                        <a:srgbClr val="D6DEE7"/>
+                      </a:solidFill>
+                      <a:prstDash val="solid"/>
+                      <a:round/>
+                      <a:headEnd type="none" w="med" len="med"/>
+                      <a:tailEnd type="none" w="med" len="med"/>
+                    </a:lnT>
+                    <a:lnB w="6350" cap="flat" cmpd="sng" algn="ctr">
+                      <a:solidFill>
+                        <a:srgbClr val="D6DEE7"/>
+                      </a:solidFill>
+                      <a:prstDash val="solid"/>
+                      <a:round/>
+                      <a:headEnd type="none" w="med" len="med"/>
+                      <a:tailEnd type="none" w="med" len="med"/>
+                    </a:lnB>
+                    <a:solidFill>
+                      <a:srgbClr val="F4F6F9"/>
+                    </a:solidFill>
+                  </a:tcPr>
+                </a:tc>
+                <a:tc>
+                  <a:txBody>
+                    <a:bodyPr/>
+                    <a:lstStyle/>
+                    <a:p>
+                      <a:pPr marL="0" indent="0" algn="l">
+                        <a:buNone/>
+                      </a:pPr>
+                      <a:r>
+                        <a:rPr lang="en-US" sz="1100" dirty="0">
+                          <a:solidFill>
+                            <a:srgbClr val="16202E"/>
+                          </a:solidFill>
+                          <a:latin typeface="Calibri" pitchFamily="34" charset="0"/>
+                          <a:ea typeface="Calibri" pitchFamily="34" charset="-122"/>
+                          <a:cs typeface="Calibri" pitchFamily="34" charset="-120"/>
+                        </a:rPr>
+                        <a:t>72.7%  /  0.672</a:t>
+                      </a:r>
+                      <a:endParaRPr lang="en-US" sz="1100" dirty="0"/>
+                    </a:p>
+                  </a:txBody>
+                  <a:tcPr marL="101600" marR="101600" marT="50800" marB="50800" anchor="ctr">
+                    <a:lnL w="6350" cap="flat" cmpd="sng" algn="ctr">
+                      <a:solidFill>
+                        <a:srgbClr val="D6DEE7"/>
+                      </a:solidFill>
+                      <a:prstDash val="solid"/>
+                      <a:round/>
+                      <a:headEnd type="none" w="med" len="med"/>
+                      <a:tailEnd type="none" w="med" len="med"/>
+                    </a:lnL>
+                    <a:lnR w="6350" cap="flat" cmpd="sng" algn="ctr">
+                      <a:solidFill>
+                        <a:srgbClr val="D6DEE7"/>
+                      </a:solidFill>
+                      <a:prstDash val="solid"/>
+                      <a:round/>
+                      <a:headEnd type="none" w="med" len="med"/>
+                      <a:tailEnd type="none" w="med" len="med"/>
+                    </a:lnR>
+                    <a:lnT w="6350" cap="flat" cmpd="sng" algn="ctr">
+                      <a:solidFill>
+                        <a:srgbClr val="D6DEE7"/>
+                      </a:solidFill>
+                      <a:prstDash val="solid"/>
+                      <a:round/>
+                      <a:headEnd type="none" w="med" len="med"/>
+                      <a:tailEnd type="none" w="med" len="med"/>
+                    </a:lnT>
+                    <a:lnB w="6350" cap="flat" cmpd="sng" algn="ctr">
+                      <a:solidFill>
+                        <a:srgbClr val="D6DEE7"/>
+                      </a:solidFill>
+                      <a:prstDash val="solid"/>
+                      <a:round/>
+                      <a:headEnd type="none" w="med" len="med"/>
+                      <a:tailEnd type="none" w="med" len="med"/>
+                    </a:lnB>
+                    <a:solidFill>
+                      <a:srgbClr val="F4F6F9"/>
+                    </a:solidFill>
+                  </a:tcPr>
+                </a:tc>
+                <a:tc>
+                  <a:txBody>
+                    <a:bodyPr/>
+                    <a:lstStyle/>
+                    <a:p>
+                      <a:pPr marL="0" indent="0" algn="l">
+                        <a:buNone/>
+                      </a:pPr>
+                      <a:r>
+                        <a:rPr lang="en-US" sz="1100" dirty="0">
+                          <a:solidFill>
+                            <a:srgbClr val="16202E"/>
+                          </a:solidFill>
+                          <a:latin typeface="Calibri" pitchFamily="34" charset="0"/>
+                          <a:ea typeface="Calibri" pitchFamily="34" charset="-122"/>
+                          <a:cs typeface="Calibri" pitchFamily="34" charset="-120"/>
+                        </a:rPr>
+                        <a:t>57.1%  /  0.656</a:t>
+                      </a:r>
+                      <a:endParaRPr lang="en-US" sz="1100" dirty="0"/>
+                    </a:p>
+                  </a:txBody>
+                  <a:tcPr marL="101600" marR="101600" marT="50800" marB="50800" anchor="ctr">
+                    <a:lnL w="6350" cap="flat" cmpd="sng" algn="ctr">
+                      <a:solidFill>
+                        <a:srgbClr val="D6DEE7"/>
+                      </a:solidFill>
+                      <a:prstDash val="solid"/>
+                      <a:round/>
+                      <a:headEnd type="none" w="med" len="med"/>
+                      <a:tailEnd type="none" w="med" len="med"/>
+                    </a:lnL>
+                    <a:lnR w="6350" cap="flat" cmpd="sng" algn="ctr">
+                      <a:solidFill>
+                        <a:srgbClr val="D6DEE7"/>
+                      </a:solidFill>
+                      <a:prstDash val="solid"/>
+                      <a:round/>
+                      <a:headEnd type="none" w="med" len="med"/>
+                      <a:tailEnd type="none" w="med" len="med"/>
+                    </a:lnR>
+                    <a:lnT w="6350" cap="flat" cmpd="sng" algn="ctr">
+                      <a:solidFill>
+                        <a:srgbClr val="D6DEE7"/>
+                      </a:solidFill>
+                      <a:prstDash val="solid"/>
+                      <a:round/>
+                      <a:headEnd type="none" w="med" len="med"/>
+                      <a:tailEnd type="none" w="med" len="med"/>
+                    </a:lnT>
+                    <a:lnB w="6350" cap="flat" cmpd="sng" algn="ctr">
+                      <a:solidFill>
+                        <a:srgbClr val="D6DEE7"/>
+                      </a:solidFill>
+                      <a:prstDash val="solid"/>
+                      <a:round/>
+                      <a:headEnd type="none" w="med" len="med"/>
+                      <a:tailEnd type="none" w="med" len="med"/>
+                    </a:lnB>
+                    <a:solidFill>
+                      <a:srgbClr val="F4F6F9"/>
+                    </a:solidFill>
+                  </a:tcPr>
+                </a:tc>
+                <a:extLst>
+                  <a:ext uri="{0D108BD9-81ED-4DB2-BD59-A6C34878D82A}">
+                    <a16:rowId xmlns:a16="http://schemas.microsoft.com/office/drawing/2014/main" val="10002"/>
+                  </a:ext>
+                </a:extLst>
+              </a:tr>
+              <a:tr h="320000">
+                <a:tc>
+                  <a:txBody>
+                    <a:bodyPr/>
+                    <a:lstStyle/>
+                    <a:p>
+                      <a:pPr marL="0" indent="0" algn="l">
+                        <a:buNone/>
+                      </a:pPr>
+                      <a:r>
+                        <a:rPr lang="en-US" sz="1100" b="1" dirty="0">
+                          <a:solidFill>
+                            <a:srgbClr val="16202E"/>
+                          </a:solidFill>
+                          <a:latin typeface="Calibri" pitchFamily="34" charset="0"/>
+                          <a:ea typeface="Calibri" pitchFamily="34" charset="-122"/>
+                          <a:cs typeface="Calibri" pitchFamily="34" charset="-120"/>
+                        </a:rPr>
+                        <a:t>Opus 4.8 ↔ DeepSeek R1</a:t>
+                      </a:r>
+                      <a:endParaRPr lang="en-US" sz="1100" dirty="0"/>
+                    </a:p>
+                  </a:txBody>
+                  <a:tcPr marL="101600" marR="101600" marT="50800" marB="50800" anchor="ctr">
+                    <a:lnL w="6350" cap="flat" cmpd="sng" algn="ctr">
+                      <a:solidFill>
+                        <a:srgbClr val="D6DEE7"/>
+                      </a:solidFill>
+                      <a:prstDash val="solid"/>
+                      <a:round/>
+                      <a:headEnd type="none" w="med" len="med"/>
+                      <a:tailEnd type="none" w="med" len="med"/>
+                    </a:lnL>
+                    <a:lnR w="6350" cap="flat" cmpd="sng" algn="ctr">
+                      <a:solidFill>
+                        <a:srgbClr val="D6DEE7"/>
+                      </a:solidFill>
+                      <a:prstDash val="solid"/>
+                      <a:round/>
+                      <a:headEnd type="none" w="med" len="med"/>
+                      <a:tailEnd type="none" w="med" len="med"/>
+                    </a:lnR>
+                    <a:lnT w="6350" cap="flat" cmpd="sng" algn="ctr">
+                      <a:solidFill>
+                        <a:srgbClr val="D6DEE7"/>
+                      </a:solidFill>
+                      <a:prstDash val="solid"/>
+                      <a:round/>
+                      <a:headEnd type="none" w="med" len="med"/>
+                      <a:tailEnd type="none" w="med" len="med"/>
+                    </a:lnT>
+                    <a:lnB w="6350" cap="flat" cmpd="sng" algn="ctr">
+                      <a:solidFill>
+                        <a:srgbClr val="D6DEE7"/>
+                      </a:solidFill>
+                      <a:prstDash val="solid"/>
+                      <a:round/>
+                      <a:headEnd type="none" w="med" len="med"/>
+                      <a:tailEnd type="none" w="med" len="med"/>
+                    </a:lnB>
+                    <a:solidFill>
+                      <a:srgbClr val="FFFFFF"/>
+                    </a:solidFill>
+                  </a:tcPr>
+                </a:tc>
+                <a:tc>
+                  <a:txBody>
+                    <a:bodyPr/>
+                    <a:lstStyle/>
+                    <a:p>
+                      <a:pPr marL="0" indent="0" algn="l">
+                        <a:buNone/>
+                      </a:pPr>
+                      <a:r>
+                        <a:rPr lang="en-US" sz="1100" dirty="0">
+                          <a:solidFill>
+                            <a:srgbClr val="16202E"/>
+                          </a:solidFill>
+                          <a:latin typeface="Calibri" pitchFamily="34" charset="0"/>
+                          <a:ea typeface="Calibri" pitchFamily="34" charset="-122"/>
+                          <a:cs typeface="Calibri" pitchFamily="34" charset="-120"/>
+                        </a:rPr>
+                        <a:t>69.7%  /  0.629</a:t>
+                      </a:r>
+                      <a:endParaRPr lang="en-US" sz="1100" dirty="0"/>
+                    </a:p>
+                  </a:txBody>
+                  <a:tcPr marL="101600" marR="101600" marT="50800" marB="50800" anchor="ctr">
+                    <a:lnL w="6350" cap="flat" cmpd="sng" algn="ctr">
+                      <a:solidFill>
+                        <a:srgbClr val="D6DEE7"/>
+                      </a:solidFill>
+                      <a:prstDash val="solid"/>
+                      <a:round/>
+                      <a:headEnd type="none" w="med" len="med"/>
+                      <a:tailEnd type="none" w="med" len="med"/>
+                    </a:lnL>
+                    <a:lnR w="6350" cap="flat" cmpd="sng" algn="ctr">
+                      <a:solidFill>
+                        <a:srgbClr val="D6DEE7"/>
+                      </a:solidFill>
+                      <a:prstDash val="solid"/>
+                      <a:round/>
+                      <a:headEnd type="none" w="med" len="med"/>
+                      <a:tailEnd type="none" w="med" len="med"/>
+                    </a:lnR>
+                    <a:lnT w="6350" cap="flat" cmpd="sng" algn="ctr">
+                      <a:solidFill>
+                        <a:srgbClr val="D6DEE7"/>
+                      </a:solidFill>
+                      <a:prstDash val="solid"/>
+                      <a:round/>
+                      <a:headEnd type="none" w="med" len="med"/>
+                      <a:tailEnd type="none" w="med" len="med"/>
+                    </a:lnT>
+                    <a:lnB w="6350" cap="flat" cmpd="sng" algn="ctr">
+                      <a:solidFill>
+                        <a:srgbClr val="D6DEE7"/>
+                      </a:solidFill>
+                      <a:prstDash val="solid"/>
+                      <a:round/>
+                      <a:headEnd type="none" w="med" len="med"/>
+                      <a:tailEnd type="none" w="med" len="med"/>
+                    </a:lnB>
+                    <a:solidFill>
+                      <a:srgbClr val="FFFFFF"/>
+                    </a:solidFill>
+                  </a:tcPr>
+                </a:tc>
+                <a:tc>
+                  <a:txBody>
+                    <a:bodyPr/>
+                    <a:lstStyle/>
+                    <a:p>
+                      <a:pPr marL="0" indent="0" algn="l">
+                        <a:buNone/>
+                      </a:pPr>
+                      <a:r>
+                        <a:rPr lang="en-US" sz="1100" dirty="0">
+                          <a:solidFill>
+                            <a:srgbClr val="16202E"/>
+                          </a:solidFill>
+                          <a:latin typeface="Calibri" pitchFamily="34" charset="0"/>
+                          <a:ea typeface="Calibri" pitchFamily="34" charset="-122"/>
+                          <a:cs typeface="Calibri" pitchFamily="34" charset="-120"/>
+                        </a:rPr>
+                        <a:t>47.5%  /  0.498</a:t>
+                      </a:r>
+                      <a:endParaRPr lang="en-US" sz="1100" dirty="0"/>
+                    </a:p>
+                  </a:txBody>
+                  <a:tcPr marL="101600" marR="101600" marT="50800" marB="50800" anchor="ctr">
+                    <a:lnL w="6350" cap="flat" cmpd="sng" algn="ctr">
+                      <a:solidFill>
+                        <a:srgbClr val="D6DEE7"/>
+                      </a:solidFill>
+                      <a:prstDash val="solid"/>
+                      <a:round/>
+                      <a:headEnd type="none" w="med" len="med"/>
+                      <a:tailEnd type="none" w="med" len="med"/>
+                    </a:lnL>
+                    <a:lnR w="6350" cap="flat" cmpd="sng" algn="ctr">
+                      <a:solidFill>
+                        <a:srgbClr val="D6DEE7"/>
+                      </a:solidFill>
+                      <a:prstDash val="solid"/>
+                      <a:round/>
+                      <a:headEnd type="none" w="med" len="med"/>
+                      <a:tailEnd type="none" w="med" len="med"/>
+                    </a:lnR>
+                    <a:lnT w="6350" cap="flat" cmpd="sng" algn="ctr">
+                      <a:solidFill>
+                        <a:srgbClr val="D6DEE7"/>
+                      </a:solidFill>
+                      <a:prstDash val="solid"/>
+                      <a:round/>
+                      <a:headEnd type="none" w="med" len="med"/>
+                      <a:tailEnd type="none" w="med" len="med"/>
+                    </a:lnT>
+                    <a:lnB w="6350" cap="flat" cmpd="sng" algn="ctr">
+                      <a:solidFill>
+                        <a:srgbClr val="D6DEE7"/>
+                      </a:solidFill>
+                      <a:prstDash val="solid"/>
+                      <a:round/>
+                      <a:headEnd type="none" w="med" len="med"/>
+                      <a:tailEnd type="none" w="med" len="med"/>
+                    </a:lnB>
+                    <a:solidFill>
+                      <a:srgbClr val="FFFFFF"/>
+                    </a:solidFill>
+                  </a:tcPr>
+                </a:tc>
+                <a:extLst>
+                  <a:ext uri="{0D108BD9-81ED-4DB2-BD59-A6C34878D82A}">
+                    <a16:rowId xmlns:a16="http://schemas.microsoft.com/office/drawing/2014/main" val="10003"/>
+                  </a:ext>
+                </a:extLst>
+              </a:tr>
+            </a:tbl>
+          </a:graphicData>
+        </a:graphic>
+      </p:graphicFrame>
+      <p:sp>
+        <p:nvSpPr>
+          <p:cNvPr id="12" name="Rectangle 11"/>
+          <p:cNvSpPr/>
+          <p:nvPr/>
+        </p:nvSpPr>
+        <p:spPr>
+          <a:xfrm>
+            <a:off x="640080" y="5670000"/>
+            <a:ext cx="11155680" cy="749808"/>
+          </a:xfrm>
+          <a:prstGeom prst="roundRect">
+            <a:avLst>
+              <a:gd name="adj" fmla="val 6000"/>
+            </a:avLst>
+          </a:prstGeom>
+          <a:solidFill>
+            <a:srgbClr val="FFFFFF"/>
+          </a:solidFill>
+          <a:ln w="9525">
+            <a:solidFill>
+              <a:srgbClr val="D6DEE7"/>
+            </a:solidFill>
+            <a:prstDash val="solid"/>
+          </a:ln>
+          <a:effectLst>
+            <a:outerShdw blurRad="101600" dist="25400" dir="5400000" algn="bl" rotWithShape="0">
+              <a:srgbClr val="5A6B7E">
+                <a:alpha val="10000"/>
+              </a:srgbClr>
+            </a:outerShdw>
+          </a:effectLst>
+        </p:spPr>
+        <p:style>
+          <a:lnRef idx="1">
+            <a:schemeClr val="accent1"/>
+          </a:lnRef>
+          <a:fillRef idx="3">
+            <a:schemeClr val="accent1"/>
+          </a:fillRef>
+          <a:effectRef idx="2">
+            <a:schemeClr val="accent1"/>
+          </a:effectRef>
+          <a:fontRef idx="minor">
+            <a:schemeClr val="lt1"/>
+          </a:fontRef>
+        </p:style>
+        <p:txBody>
+          <a:bodyPr rtlCol="0" anchor="ctr"/>
+          <a:lstStyle/>
+          <a:p>
+            <a:pPr algn="ctr"/>
+            <a:endParaRPr/>
+          </a:p>
+        </p:txBody>
+      </p:sp>
+      <p:sp>
+        <p:nvSpPr>
+          <p:cNvPr id="13" name="TextBox 12"/>
+          <p:cNvSpPr txBox="1"/>
+          <p:nvPr/>
+        </p:nvSpPr>
+        <p:spPr>
+          <a:xfrm>
+            <a:off x="795528" y="5902557"/>
+            <a:ext cx="10835640" cy="284693"/>
+          </a:xfrm>
+          <a:prstGeom prst="rect">
+            <a:avLst/>
+          </a:prstGeom>
+          <a:noFill/>
+        </p:spPr>
+        <p:txBody>
+          <a:bodyPr wrap="square" anchor="ctr">
+            <a:spAutoFit/>
+          </a:bodyPr>
+          <a:lstStyle/>
+          <a:p>
+            <a:pPr algn="l">
+              <a:spcAft>
+                <a:spcPts val="400"/>
+              </a:spcAft>
+            </a:pPr>
+            <a:r>
+              <a:rPr sz="1250" b="0" dirty="0">
+                <a:solidFill>
+                  <a:srgbClr val="16202E"/>
+                </a:solidFill>
+                <a:latin typeface="Calibri"/>
+              </a:rPr>
+              <a:t>Relevance agreement </a:t>
+            </a:r>
+            <a:r>
+              <a:rPr sz="1250" b="0">
+                <a:solidFill>
+                  <a:srgbClr val="16202E"/>
+                </a:solidFill>
+                <a:latin typeface="Calibri"/>
+              </a:rPr>
+              <a:t>is strong; </a:t>
+            </a:r>
+            <a:r>
+              <a:rPr sz="1250" b="0" dirty="0">
+                <a:solidFill>
+                  <a:srgbClr val="16202E"/>
+                </a:solidFill>
+                <a:latin typeface="Calibri"/>
+              </a:rPr>
+              <a:t>Quality </a:t>
+            </a:r>
+            <a:r>
+              <a:rPr sz="1250" b="0">
+                <a:solidFill>
+                  <a:srgbClr val="16202E"/>
+                </a:solidFill>
+                <a:latin typeface="Calibri"/>
+              </a:rPr>
+              <a:t>is </a:t>
+            </a:r>
+            <a:r>
+              <a:rPr lang="en-US" sz="1250">
+                <a:solidFill>
+                  <a:srgbClr val="16202E"/>
+                </a:solidFill>
+                <a:latin typeface="Calibri"/>
+              </a:rPr>
+              <a:t>weaker. </a:t>
+            </a:r>
+            <a:endParaRPr sz="1250" b="0" dirty="0">
+              <a:solidFill>
+                <a:srgbClr val="16202E"/>
+              </a:solidFill>
+              <a:latin typeface="Calibri"/>
+            </a:endParaRPr>
+          </a:p>
+        </p:txBody>
+      </p:sp>
+      <p:sp>
+        <p:nvSpPr>
+          <p:cNvPr id="14" name="TextBox 13"/>
+          <p:cNvSpPr txBox="1"/>
+          <p:nvPr/>
+        </p:nvSpPr>
+        <p:spPr>
+          <a:xfrm>
+            <a:off x="640080" y="6473952"/>
+            <a:ext cx="7315200" cy="274320"/>
+          </a:xfrm>
+          <a:prstGeom prst="rect">
+            <a:avLst/>
+          </a:prstGeom>
+          <a:noFill/>
+        </p:spPr>
+        <p:txBody>
+          <a:bodyPr wrap="square" anchor="t">
+            <a:spAutoFit/>
+          </a:bodyPr>
+          <a:lstStyle/>
+          <a:p>
+            <a:pPr algn="l">
+              <a:spcAft>
+                <a:spcPts val="400"/>
+              </a:spcAft>
+            </a:pPr>
+            <a:r>
+              <a:rPr sz="900" b="0">
+                <a:solidFill>
+                  <a:srgbClr val="93A1B2"/>
+                </a:solidFill>
+                <a:latin typeface="Calibri"/>
+              </a:rPr>
+              <a:t>Deep Research Agent  ·  Neha Anna John</a:t>
+            </a:r>
+          </a:p>
+        </p:txBody>
+      </p:sp>
+      <p:sp>
+        <p:nvSpPr>
+          <p:cNvPr id="15" name="TextBox 14"/>
+          <p:cNvSpPr txBox="1"/>
+          <p:nvPr/>
+        </p:nvSpPr>
+        <p:spPr>
+          <a:xfrm>
+            <a:off x="11002975" y="6473952"/>
+            <a:ext cx="548640" cy="274320"/>
+          </a:xfrm>
+          <a:prstGeom prst="rect">
+            <a:avLst/>
+          </a:prstGeom>
+          <a:noFill/>
+        </p:spPr>
+        <p:txBody>
+          <a:bodyPr wrap="square" anchor="t">
+            <a:spAutoFit/>
+          </a:bodyPr>
+          <a:lstStyle/>
+          <a:p>
+            <a:pPr algn="r">
+              <a:spcAft>
+                <a:spcPts val="400"/>
+              </a:spcAft>
+            </a:pPr>
+            <a:r>
+              <a:rPr sz="900" b="0">
+                <a:solidFill>
+                  <a:srgbClr val="93A1B2"/>
+                </a:solidFill>
+                <a:latin typeface="Calibri"/>
+              </a:rPr>
+              <a:t>20</a:t>
+            </a:r>
+          </a:p>
+        </p:txBody>
+      </p:sp>
+    </p:spTree>
+  </p:cSld>
+  <p:clrMapOvr>
+    <a:masterClrMapping/>
+  </p:clrMapOvr>
+</p:sld>
+</file>
+
+<file path=ppt/slides/slide22.xml><?xml version="1.0" encoding="utf-8"?>
+<p:sld xmlns:a="http://schemas.openxmlformats.org/drawingml/2006/main" xmlns:r="http://schemas.openxmlformats.org/officeDocument/2006/relationships" xmlns:p="http://schemas.openxmlformats.org/presentationml/2006/main">
   <p:cSld name="Slide 22">
     <p:bg>
       <p:bgPr>
@@ -23909,7 +26117,7 @@
                 <a:ea typeface="Calibri" pitchFamily="34" charset="-122"/>
                 <a:cs typeface="Calibri" pitchFamily="34" charset="-120"/>
               </a:rPr>
-              <a:t>20</a:t>
+              <a:t>21</a:t>
             </a:r>
             <a:endParaRPr lang="en-US" sz="950" dirty="0"/>
           </a:p>
@@ -23923,7 +26131,7 @@
 </p:sld>
 </file>
 
-<file path=ppt/slides/slide22.xml><?xml version="1.0" encoding="utf-8"?>
+<file path=ppt/slides/slide23.xml><?xml version="1.0" encoding="utf-8"?>
 <p:sld xmlns:a="http://schemas.openxmlformats.org/drawingml/2006/main" xmlns:r="http://schemas.openxmlformats.org/officeDocument/2006/relationships" xmlns:p="http://schemas.openxmlformats.org/presentationml/2006/main">
   <p:cSld name="Slide 7">
     <p:bg>
@@ -25031,7 +27239,7 @@
                 <a:ea typeface="Calibri" pitchFamily="34" charset="-122"/>
                 <a:cs typeface="Calibri" pitchFamily="34" charset="-120"/>
               </a:rPr>
-              <a:t>21</a:t>
+              <a:t>22</a:t>
             </a:r>
             <a:endParaRPr lang="en-US" sz="950" dirty="0"/>
           </a:p>
@@ -25045,7 +27253,7 @@
 </p:sld>
 </file>
 
-<file path=ppt/slides/slide23.xml><?xml version="1.0" encoding="utf-8"?>
+<file path=ppt/slides/slide24.xml><?xml version="1.0" encoding="utf-8"?>
 <p:sld xmlns:a="http://schemas.openxmlformats.org/drawingml/2006/main" xmlns:r="http://schemas.openxmlformats.org/officeDocument/2006/relationships" xmlns:p="http://schemas.openxmlformats.org/presentationml/2006/main">
   <p:cSld name="Slide 23">
     <p:bg>
@@ -27112,7 +29320,7 @@
                 <a:ea typeface="Calibri" pitchFamily="34" charset="-122"/>
                 <a:cs typeface="Calibri" pitchFamily="34" charset="-120"/>
               </a:rPr>
-              <a:t>22</a:t>
+              <a:t>23</a:t>
             </a:r>
             <a:endParaRPr lang="en-US" sz="950" dirty="0"/>
           </a:p>
@@ -27126,7 +29334,7 @@
 </p:sld>
 </file>
 
-<file path=ppt/slides/slide24.xml><?xml version="1.0" encoding="utf-8"?>
+<file path=ppt/slides/slide25.xml><?xml version="1.0" encoding="utf-8"?>
 <p:sld xmlns:a="http://schemas.openxmlformats.org/drawingml/2006/main" xmlns:r="http://schemas.openxmlformats.org/officeDocument/2006/relationships" xmlns:p="http://schemas.openxmlformats.org/presentationml/2006/main">
   <p:cSld name="Slide 24">
     <p:bg>
@@ -27494,7 +29702,7 @@
                 <a:ea typeface="Calibri" pitchFamily="34" charset="-122"/>
                 <a:cs typeface="Calibri" pitchFamily="34" charset="-120"/>
               </a:rPr>
-              <a:t>23</a:t>
+              <a:t>24</a:t>
             </a:r>
             <a:endParaRPr lang="en-US" sz="950" dirty="0"/>
           </a:p>
@@ -27508,7 +29716,7 @@
 </p:sld>
 </file>
 
-<file path=ppt/slides/slide25.xml><?xml version="1.0" encoding="utf-8"?>
+<file path=ppt/slides/slide26.xml><?xml version="1.0" encoding="utf-8"?>
 <p:sld xmlns:a="http://schemas.openxmlformats.org/drawingml/2006/main" xmlns:r="http://schemas.openxmlformats.org/officeDocument/2006/relationships" xmlns:p="http://schemas.openxmlformats.org/presentationml/2006/main">
   <p:cSld name="Slide 25">
     <p:bg>
@@ -28277,7 +30485,7 @@
                 <a:ea typeface="Calibri" pitchFamily="34" charset="-122"/>
                 <a:cs typeface="Calibri" pitchFamily="34" charset="-120"/>
               </a:rPr>
-              <a:t>24</a:t>
+              <a:t>25</a:t>
             </a:r>
             <a:endParaRPr lang="en-US" sz="950" dirty="0"/>
           </a:p>
@@ -28291,7 +30499,7 @@
 </p:sld>
 </file>
 
-<file path=ppt/slides/slide26.xml><?xml version="1.0" encoding="utf-8"?>
+<file path=ppt/slides/slide27.xml><?xml version="1.0" encoding="utf-8"?>
 <p:sld xmlns:a="http://schemas.openxmlformats.org/drawingml/2006/main" xmlns:r="http://schemas.openxmlformats.org/officeDocument/2006/relationships" xmlns:p="http://schemas.openxmlformats.org/presentationml/2006/main">
   <p:cSld name="Slide 26">
     <p:bg>
@@ -28825,7 +31033,7 @@
                 <a:ea typeface="Calibri" pitchFamily="34" charset="-122"/>
                 <a:cs typeface="Calibri" pitchFamily="34" charset="-120"/>
               </a:rPr>
-              <a:t>25</a:t>
+              <a:t>26</a:t>
             </a:r>
             <a:endParaRPr lang="en-US" sz="950" dirty="0"/>
           </a:p>
@@ -28839,7 +31047,7 @@
 </p:sld>
 </file>
 
-<file path=ppt/slides/slide27.xml><?xml version="1.0" encoding="utf-8"?>
+<file path=ppt/slides/slide28.xml><?xml version="1.0" encoding="utf-8"?>
 <p:sld xmlns:a="http://schemas.openxmlformats.org/drawingml/2006/main" xmlns:r="http://schemas.openxmlformats.org/officeDocument/2006/relationships" xmlns:p="http://schemas.openxmlformats.org/presentationml/2006/main">
   <p:cSld name="Slide 27">
     <p:bg>
@@ -30120,7 +32328,7 @@
                 <a:ea typeface="Calibri" pitchFamily="34" charset="-122"/>
                 <a:cs typeface="Calibri" pitchFamily="34" charset="-120"/>
               </a:rPr>
-              <a:t>26</a:t>
+              <a:t>27</a:t>
             </a:r>
             <a:endParaRPr lang="en-US" sz="950" dirty="0"/>
           </a:p>
@@ -30134,7 +32342,7 @@
 </p:sld>
 </file>
 
-<file path=ppt/slides/slide28.xml><?xml version="1.0" encoding="utf-8"?>
+<file path=ppt/slides/slide29.xml><?xml version="1.0" encoding="utf-8"?>
 <p:sld xmlns:a="http://schemas.openxmlformats.org/drawingml/2006/main" xmlns:r="http://schemas.openxmlformats.org/officeDocument/2006/relationships" xmlns:p="http://schemas.openxmlformats.org/presentationml/2006/main">
   <p:cSld name="Slide 28">
     <p:bg>
@@ -31039,671 +33247,6 @@
       <p:sp>
         <p:nvSpPr>
           <p:cNvPr id="32" name="Text 25"/>
-          <p:cNvSpPr/>
-          <p:nvPr/>
-        </p:nvSpPr>
-        <p:spPr>
-          <a:xfrm>
-            <a:off x="11002975" y="6473952"/>
-            <a:ext cx="548640" cy="274320"/>
-          </a:xfrm>
-          <a:prstGeom prst="rect">
-            <a:avLst/>
-          </a:prstGeom>
-          <a:noFill/>
-          <a:ln/>
-        </p:spPr>
-        <p:txBody>
-          <a:bodyPr wrap="square" lIns="0" tIns="0" rIns="0" bIns="0" rtlCol="0" anchor="ctr"/>
-          <a:lstStyle/>
-          <a:p>
-            <a:pPr marL="0" indent="0" algn="r">
-              <a:buNone/>
-            </a:pPr>
-            <a:r>
-              <a:rPr lang="en-US" sz="950" b="1" dirty="0">
-                <a:solidFill>
-                  <a:srgbClr val="93A1B2"/>
-                </a:solidFill>
-                <a:latin typeface="Calibri" pitchFamily="34" charset="0"/>
-                <a:ea typeface="Calibri" pitchFamily="34" charset="-122"/>
-                <a:cs typeface="Calibri" pitchFamily="34" charset="-120"/>
-              </a:rPr>
-              <a:t>27</a:t>
-            </a:r>
-            <a:endParaRPr lang="en-US" sz="950" dirty="0"/>
-          </a:p>
-        </p:txBody>
-      </p:sp>
-    </p:spTree>
-  </p:cSld>
-  <p:clrMapOvr>
-    <a:masterClrMapping/>
-  </p:clrMapOvr>
-</p:sld>
-</file>
-
-<file path=ppt/slides/slide29.xml><?xml version="1.0" encoding="utf-8"?>
-<p:sld xmlns:a="http://schemas.openxmlformats.org/drawingml/2006/main" xmlns:r="http://schemas.openxmlformats.org/officeDocument/2006/relationships" xmlns:p="http://schemas.openxmlformats.org/presentationml/2006/main">
-  <p:cSld name="Slide 29">
-    <p:bg>
-      <p:bgPr>
-        <a:solidFill>
-          <a:srgbClr val="F4F6F9"/>
-        </a:solidFill>
-        <a:effectLst/>
-      </p:bgPr>
-    </p:bg>
-    <p:spTree>
-      <p:nvGrpSpPr>
-        <p:cNvPr id="1" name=""/>
-        <p:cNvGrpSpPr/>
-        <p:nvPr/>
-      </p:nvGrpSpPr>
-      <p:grpSpPr>
-        <a:xfrm>
-          <a:off x="0" y="0"/>
-          <a:ext cx="0" cy="0"/>
-          <a:chOff x="0" y="0"/>
-          <a:chExt cx="0" cy="0"/>
-        </a:xfrm>
-      </p:grpSpPr>
-      <p:sp>
-        <p:nvSpPr>
-          <p:cNvPr id="2" name="Shape 0"/>
-          <p:cNvSpPr/>
-          <p:nvPr/>
-        </p:nvSpPr>
-        <p:spPr>
-          <a:xfrm>
-            <a:off x="640080" y="475488"/>
-            <a:ext cx="329184" cy="329184"/>
-          </a:xfrm>
-          <a:prstGeom prst="roundRect">
-            <a:avLst>
-              <a:gd name="adj" fmla="val 19444"/>
-            </a:avLst>
-          </a:prstGeom>
-          <a:solidFill>
-            <a:srgbClr val="0D9488"/>
-          </a:solidFill>
-          <a:ln/>
-        </p:spPr>
-        <p:txBody>
-          <a:bodyPr/>
-          <a:lstStyle/>
-          <a:p>
-            <a:endParaRPr lang="en-US"/>
-          </a:p>
-        </p:txBody>
-      </p:sp>
-      <p:sp>
-        <p:nvSpPr>
-          <p:cNvPr id="3" name="Text 1"/>
-          <p:cNvSpPr/>
-          <p:nvPr/>
-        </p:nvSpPr>
-        <p:spPr>
-          <a:xfrm>
-            <a:off x="640080" y="475488"/>
-            <a:ext cx="329184" cy="329184"/>
-          </a:xfrm>
-          <a:prstGeom prst="rect">
-            <a:avLst/>
-          </a:prstGeom>
-          <a:noFill/>
-          <a:ln/>
-        </p:spPr>
-        <p:txBody>
-          <a:bodyPr wrap="square" lIns="0" tIns="0" rIns="0" bIns="0" rtlCol="0" anchor="ctr"/>
-          <a:lstStyle/>
-          <a:p>
-            <a:pPr marL="0" indent="0" algn="ctr">
-              <a:buNone/>
-            </a:pPr>
-            <a:r>
-              <a:rPr lang="en-US" sz="1500" b="1" dirty="0">
-                <a:solidFill>
-                  <a:srgbClr val="FFFFFF"/>
-                </a:solidFill>
-                <a:latin typeface="Calibri" pitchFamily="34" charset="0"/>
-                <a:ea typeface="Calibri" pitchFamily="34" charset="-122"/>
-                <a:cs typeface="Calibri" pitchFamily="34" charset="-120"/>
-              </a:rPr>
-              <a:t>9</a:t>
-            </a:r>
-            <a:endParaRPr lang="en-US" sz="1500" dirty="0"/>
-          </a:p>
-        </p:txBody>
-      </p:sp>
-      <p:sp>
-        <p:nvSpPr>
-          <p:cNvPr id="4" name="Text 2"/>
-          <p:cNvSpPr/>
-          <p:nvPr/>
-        </p:nvSpPr>
-        <p:spPr>
-          <a:xfrm>
-            <a:off x="1097280" y="475488"/>
-            <a:ext cx="8229600" cy="329184"/>
-          </a:xfrm>
-          <a:prstGeom prst="rect">
-            <a:avLst/>
-          </a:prstGeom>
-          <a:noFill/>
-          <a:ln/>
-        </p:spPr>
-        <p:txBody>
-          <a:bodyPr wrap="square" lIns="0" tIns="0" rIns="0" bIns="0" rtlCol="0" anchor="ctr"/>
-          <a:lstStyle/>
-          <a:p>
-            <a:pPr marL="0" indent="0">
-              <a:buNone/>
-            </a:pPr>
-            <a:r>
-              <a:rPr lang="en-US" sz="1250" b="1" kern="0" spc="240" dirty="0">
-                <a:solidFill>
-                  <a:srgbClr val="0D9488"/>
-                </a:solidFill>
-                <a:latin typeface="Calibri" pitchFamily="34" charset="0"/>
-                <a:ea typeface="Calibri" pitchFamily="34" charset="-122"/>
-                <a:cs typeface="Calibri" pitchFamily="34" charset="-120"/>
-              </a:rPr>
-              <a:t>EXTENSIONS</a:t>
-            </a:r>
-            <a:endParaRPr lang="en-US" sz="1250" dirty="0"/>
-          </a:p>
-        </p:txBody>
-      </p:sp>
-      <p:sp>
-        <p:nvSpPr>
-          <p:cNvPr id="5" name="Text 3"/>
-          <p:cNvSpPr/>
-          <p:nvPr/>
-        </p:nvSpPr>
-        <p:spPr>
-          <a:xfrm>
-            <a:off x="640080" y="841248"/>
-            <a:ext cx="10911535" cy="822960"/>
-          </a:xfrm>
-          <a:prstGeom prst="rect">
-            <a:avLst/>
-          </a:prstGeom>
-          <a:noFill/>
-          <a:ln/>
-        </p:spPr>
-        <p:txBody>
-          <a:bodyPr wrap="square" lIns="0" tIns="0" rIns="0" bIns="0" rtlCol="0" anchor="t"/>
-          <a:lstStyle/>
-          <a:p>
-            <a:pPr marL="0" indent="0">
-              <a:buNone/>
-            </a:pPr>
-            <a:r>
-              <a:rPr lang="en-US" sz="3000" b="1" dirty="0">
-                <a:solidFill>
-                  <a:srgbClr val="16202E"/>
-                </a:solidFill>
-                <a:latin typeface="Calibri" pitchFamily="34" charset="0"/>
-                <a:ea typeface="Calibri" pitchFamily="34" charset="-122"/>
-                <a:cs typeface="Calibri" pitchFamily="34" charset="-120"/>
-              </a:rPr>
-              <a:t>Adaptive retrieval</a:t>
-            </a:r>
-            <a:endParaRPr lang="en-US" sz="3000" dirty="0"/>
-          </a:p>
-        </p:txBody>
-      </p:sp>
-      <p:sp>
-        <p:nvSpPr>
-          <p:cNvPr id="600" name="Intro"/>
-          <p:cNvSpPr txBox="1"/>
-          <p:nvPr/>
-        </p:nvSpPr>
-        <p:spPr>
-          <a:xfrm>
-            <a:off x="640080" y="1590000"/>
-            <a:ext cx="10911535" cy="980000"/>
-          </a:xfrm>
-          <a:prstGeom prst="rect">
-            <a:avLst/>
-          </a:prstGeom>
-        </p:spPr>
-        <p:txBody>
-          <a:bodyPr wrap="square" lIns="0" tIns="0" rIns="0" bIns="0" rtlCol="0" anchor="t"/>
-          <a:lstStyle/>
-          <a:p>
-            <a:pPr marL="0" indent="0">
-              <a:lnSpc>
-                <a:spcPct val="106000"/>
-              </a:lnSpc>
-              <a:buNone/>
-            </a:pPr>
-            <a:r>
-              <a:rPr lang="en-US" sz="1200" b="1" dirty="0">
-                <a:solidFill>
-                  <a:srgbClr val="0D9488"/>
-                </a:solidFill>
-                <a:latin typeface="Calibri" pitchFamily="34" charset="0"/>
-                <a:ea typeface="Calibri" pitchFamily="34" charset="-122"/>
-                <a:cs typeface="Calibri" pitchFamily="34" charset="-120"/>
-              </a:rPr>
-              <a:t>What it is — </a:t>
-            </a:r>
-            <a:r>
-              <a:rPr lang="en-US" sz="1200" dirty="0">
-                <a:solidFill>
-                  <a:srgbClr val="566576"/>
-                </a:solidFill>
-                <a:latin typeface="Calibri" pitchFamily="34" charset="0"/>
-                <a:ea typeface="Calibri" pitchFamily="34" charset="-122"/>
-                <a:cs typeface="Calibri" pitchFamily="34" charset="-120"/>
-              </a:rPr>
-              <a:t>replace the fixed retrieval policy with one that decides when and how to search again — multiple engines, routing by question type, and re-querying when the verifier flags weak evidence.</a:t>
-            </a:r>
-          </a:p>
-          <a:p>
-            <a:pPr marL="0" indent="0">
-              <a:spcBef>
-                <a:spcPts val="600"/>
-              </a:spcBef>
-              <a:buNone/>
-            </a:pPr>
-            <a:r>
-              <a:rPr lang="en-US" sz="1200" b="1" dirty="0">
-                <a:solidFill>
-                  <a:srgbClr val="0D9488"/>
-                </a:solidFill>
-                <a:latin typeface="Calibri" pitchFamily="34" charset="0"/>
-                <a:ea typeface="Calibri" pitchFamily="34" charset="-122"/>
-                <a:cs typeface="Calibri" pitchFamily="34" charset="-120"/>
-              </a:rPr>
-              <a:t>How it builds on this work — </a:t>
-            </a:r>
-            <a:r>
-              <a:rPr lang="en-US" sz="1200" dirty="0">
-                <a:solidFill>
-                  <a:srgbClr val="566576"/>
-                </a:solidFill>
-                <a:latin typeface="Calibri" pitchFamily="34" charset="0"/>
-                <a:ea typeface="Calibri" pitchFamily="34" charset="-122"/>
-                <a:cs typeface="Calibri" pitchFamily="34" charset="-120"/>
-              </a:rPr>
-              <a:t>the trained verifier already produces a per-claim support signal; that signal becomes the trigger for another retrieval round.</a:t>
-            </a:r>
-          </a:p>
-        </p:txBody>
-      </p:sp>
-      <p:sp>
-        <p:nvSpPr>
-          <p:cNvPr id="610" name="Strengths BG"/>
-          <p:cNvSpPr/>
-          <p:nvPr/>
-        </p:nvSpPr>
-        <p:spPr>
-          <a:xfrm>
-            <a:off x="640080" y="2660000"/>
-            <a:ext cx="5300320" cy="2880000"/>
-          </a:xfrm>
-          <a:prstGeom prst="roundRect">
-            <a:avLst>
-              <a:gd name="adj" fmla="val 3500"/>
-            </a:avLst>
-          </a:prstGeom>
-          <a:solidFill>
-            <a:srgbClr val="FFFFFF"/>
-          </a:solidFill>
-          <a:ln w="9525">
-            <a:solidFill>
-              <a:srgbClr val="D6DEE7"/>
-            </a:solidFill>
-          </a:ln>
-        </p:spPr>
-        <p:txBody>
-          <a:bodyPr/>
-          <a:lstStyle/>
-          <a:p>
-            <a:pPr>
-              <a:buNone/>
-            </a:pPr>
-            <a:endParaRPr lang="en-US"/>
-          </a:p>
-        </p:txBody>
-      </p:sp>
-      <p:sp>
-        <p:nvSpPr>
-          <p:cNvPr id="611" name="Strengths Head"/>
-          <p:cNvSpPr txBox="1"/>
-          <p:nvPr/>
-        </p:nvSpPr>
-        <p:spPr>
-          <a:xfrm>
-            <a:off x="920080" y="2860000"/>
-            <a:ext cx="4740320" cy="360000"/>
-          </a:xfrm>
-          <a:prstGeom prst="rect">
-            <a:avLst/>
-          </a:prstGeom>
-        </p:spPr>
-        <p:txBody>
-          <a:bodyPr wrap="square" lIns="0" tIns="0" rIns="0" bIns="0" rtlCol="0" anchor="t"/>
-          <a:lstStyle/>
-          <a:p>
-            <a:pPr marL="0" indent="0">
-              <a:buNone/>
-            </a:pPr>
-            <a:r>
-              <a:rPr lang="en-US" sz="1300" b="1" dirty="0">
-                <a:solidFill>
-                  <a:srgbClr val="1F9D57"/>
-                </a:solidFill>
-                <a:latin typeface="Calibri" pitchFamily="34" charset="0"/>
-                <a:ea typeface="Calibri" pitchFamily="34" charset="-122"/>
-                <a:cs typeface="Calibri" pitchFamily="34" charset="-120"/>
-              </a:rPr>
-              <a:t>Strengths</a:t>
-            </a:r>
-          </a:p>
-        </p:txBody>
-      </p:sp>
-      <p:sp>
-        <p:nvSpPr>
-          <p:cNvPr id="612" name="Strengths Bullets"/>
-          <p:cNvSpPr txBox="1"/>
-          <p:nvPr/>
-        </p:nvSpPr>
-        <p:spPr>
-          <a:xfrm>
-            <a:off x="920080" y="3320000"/>
-            <a:ext cx="4740320" cy="2060000"/>
-          </a:xfrm>
-          <a:prstGeom prst="rect">
-            <a:avLst/>
-          </a:prstGeom>
-        </p:spPr>
-        <p:txBody>
-          <a:bodyPr wrap="square" lIns="0" tIns="0" rIns="0" bIns="0" rtlCol="0" anchor="t"/>
-          <a:lstStyle/>
-          <a:p>
-            <a:pPr marL="200000" indent="-200000">
-              <a:lnSpc>
-                <a:spcPct val="106000"/>
-              </a:lnSpc>
-              <a:spcAft>
-                <a:spcPts val="900"/>
-              </a:spcAft>
-              <a:buSzPct val="100000"/>
-              <a:buFont typeface="Calibri" pitchFamily="34" charset="0"/>
-              <a:buChar char="•"/>
-            </a:pPr>
-            <a:r>
-              <a:rPr lang="en-US" sz="1100" dirty="0">
-                <a:solidFill>
-                  <a:srgbClr val="566576"/>
-                </a:solidFill>
-                <a:latin typeface="Calibri" pitchFamily="34" charset="0"/>
-                <a:ea typeface="Calibri" pitchFamily="34" charset="-122"/>
-                <a:cs typeface="Calibri" pitchFamily="34" charset="-120"/>
-              </a:rPr>
-              <a:t>Directly raises the coverage ceiling identified earlier</a:t>
-            </a:r>
-          </a:p>
-          <a:p>
-            <a:pPr marL="200000" indent="-200000">
-              <a:lnSpc>
-                <a:spcPct val="106000"/>
-              </a:lnSpc>
-              <a:spcAft>
-                <a:spcPts val="900"/>
-              </a:spcAft>
-              <a:buSzPct val="100000"/>
-              <a:buFont typeface="Calibri" pitchFamily="34" charset="0"/>
-              <a:buChar char="•"/>
-            </a:pPr>
-            <a:r>
-              <a:rPr lang="en-US" sz="1100" dirty="0">
-                <a:solidFill>
-                  <a:srgbClr val="566576"/>
-                </a:solidFill>
-                <a:latin typeface="Calibri" pitchFamily="34" charset="0"/>
-                <a:ea typeface="Calibri" pitchFamily="34" charset="-122"/>
-                <a:cs typeface="Calibri" pitchFamily="34" charset="-120"/>
-              </a:rPr>
-              <a:t>Reuses the existing verifier signal — no new reward model needed</a:t>
-            </a:r>
-          </a:p>
-          <a:p>
-            <a:pPr marL="200000" indent="-200000">
-              <a:lnSpc>
-                <a:spcPct val="106000"/>
-              </a:lnSpc>
-              <a:spcAft>
-                <a:spcPts val="900"/>
-              </a:spcAft>
-              <a:buSzPct val="100000"/>
-              <a:buFont typeface="Calibri" pitchFamily="34" charset="0"/>
-              <a:buChar char="•"/>
-            </a:pPr>
-            <a:r>
-              <a:rPr lang="en-US" sz="1100" dirty="0">
-                <a:solidFill>
-                  <a:srgbClr val="566576"/>
-                </a:solidFill>
-                <a:latin typeface="Calibri" pitchFamily="34" charset="0"/>
-                <a:ea typeface="Calibri" pitchFamily="34" charset="-122"/>
-                <a:cs typeface="Calibri" pitchFamily="34" charset="-120"/>
-              </a:rPr>
-              <a:t>Routing by question type sends each sub-query to the best engine</a:t>
-            </a:r>
-          </a:p>
-        </p:txBody>
-      </p:sp>
-      <p:sp>
-        <p:nvSpPr>
-          <p:cNvPr id="620" name="Tradeoffs BG"/>
-          <p:cNvSpPr/>
-          <p:nvPr/>
-        </p:nvSpPr>
-        <p:spPr>
-          <a:xfrm>
-            <a:off x="6251296" y="2660000"/>
-            <a:ext cx="5300320" cy="2880000"/>
-          </a:xfrm>
-          <a:prstGeom prst="roundRect">
-            <a:avLst>
-              <a:gd name="adj" fmla="val 3500"/>
-            </a:avLst>
-          </a:prstGeom>
-          <a:solidFill>
-            <a:srgbClr val="FFFFFF"/>
-          </a:solidFill>
-          <a:ln w="9525">
-            <a:solidFill>
-              <a:srgbClr val="D6DEE7"/>
-            </a:solidFill>
-          </a:ln>
-        </p:spPr>
-        <p:txBody>
-          <a:bodyPr/>
-          <a:lstStyle/>
-          <a:p>
-            <a:pPr>
-              <a:buNone/>
-            </a:pPr>
-            <a:endParaRPr lang="en-US"/>
-          </a:p>
-        </p:txBody>
-      </p:sp>
-      <p:sp>
-        <p:nvSpPr>
-          <p:cNvPr id="621" name="Tradeoffs Head"/>
-          <p:cNvSpPr txBox="1"/>
-          <p:nvPr/>
-        </p:nvSpPr>
-        <p:spPr>
-          <a:xfrm>
-            <a:off x="6531296" y="2860000"/>
-            <a:ext cx="4740320" cy="360000"/>
-          </a:xfrm>
-          <a:prstGeom prst="rect">
-            <a:avLst/>
-          </a:prstGeom>
-        </p:spPr>
-        <p:txBody>
-          <a:bodyPr wrap="square" lIns="0" tIns="0" rIns="0" bIns="0" rtlCol="0" anchor="t"/>
-          <a:lstStyle/>
-          <a:p>
-            <a:pPr marL="0" indent="0">
-              <a:buNone/>
-            </a:pPr>
-            <a:r>
-              <a:rPr lang="en-US" sz="1300" b="1" dirty="0">
-                <a:solidFill>
-                  <a:srgbClr val="B07A0C"/>
-                </a:solidFill>
-                <a:latin typeface="Calibri" pitchFamily="34" charset="0"/>
-                <a:ea typeface="Calibri" pitchFamily="34" charset="-122"/>
-                <a:cs typeface="Calibri" pitchFamily="34" charset="-120"/>
-              </a:rPr>
-              <a:t>Trade-offs / risks</a:t>
-            </a:r>
-          </a:p>
-        </p:txBody>
-      </p:sp>
-      <p:sp>
-        <p:nvSpPr>
-          <p:cNvPr id="622" name="Tradeoffs Bullets"/>
-          <p:cNvSpPr txBox="1"/>
-          <p:nvPr/>
-        </p:nvSpPr>
-        <p:spPr>
-          <a:xfrm>
-            <a:off x="6531296" y="3320000"/>
-            <a:ext cx="4740320" cy="2060000"/>
-          </a:xfrm>
-          <a:prstGeom prst="rect">
-            <a:avLst/>
-          </a:prstGeom>
-        </p:spPr>
-        <p:txBody>
-          <a:bodyPr wrap="square" lIns="0" tIns="0" rIns="0" bIns="0" rtlCol="0" anchor="t"/>
-          <a:lstStyle/>
-          <a:p>
-            <a:pPr marL="200000" indent="-200000">
-              <a:lnSpc>
-                <a:spcPct val="106000"/>
-              </a:lnSpc>
-              <a:spcAft>
-                <a:spcPts val="900"/>
-              </a:spcAft>
-              <a:buSzPct val="100000"/>
-              <a:buFont typeface="Calibri" pitchFamily="34" charset="0"/>
-              <a:buChar char="•"/>
-            </a:pPr>
-            <a:r>
-              <a:rPr lang="en-US" sz="1100" dirty="0">
-                <a:solidFill>
-                  <a:srgbClr val="566576"/>
-                </a:solidFill>
-                <a:latin typeface="Calibri" pitchFamily="34" charset="0"/>
-                <a:ea typeface="Calibri" pitchFamily="34" charset="-122"/>
-                <a:cs typeface="Calibri" pitchFamily="34" charset="-120"/>
-              </a:rPr>
-              <a:t>Cannot beat the absolute search ceiling — if evidence is not indexed, smarter search does not help</a:t>
-            </a:r>
-          </a:p>
-          <a:p>
-            <a:pPr marL="200000" indent="-200000">
-              <a:lnSpc>
-                <a:spcPct val="106000"/>
-              </a:lnSpc>
-              <a:spcAft>
-                <a:spcPts val="900"/>
-              </a:spcAft>
-              <a:buSzPct val="100000"/>
-              <a:buFont typeface="Calibri" pitchFamily="34" charset="0"/>
-              <a:buChar char="•"/>
-            </a:pPr>
-            <a:r>
-              <a:rPr lang="en-US" sz="1100" dirty="0">
-                <a:solidFill>
-                  <a:srgbClr val="566576"/>
-                </a:solidFill>
-                <a:latin typeface="Calibri" pitchFamily="34" charset="0"/>
-                <a:ea typeface="Calibri" pitchFamily="34" charset="-122"/>
-                <a:cs typeface="Calibri" pitchFamily="34" charset="-120"/>
-              </a:rPr>
-              <a:t>Re-querying adds latency and cost per question</a:t>
-            </a:r>
-          </a:p>
-          <a:p>
-            <a:pPr marL="200000" indent="-200000">
-              <a:lnSpc>
-                <a:spcPct val="106000"/>
-              </a:lnSpc>
-              <a:spcAft>
-                <a:spcPts val="900"/>
-              </a:spcAft>
-              <a:buSzPct val="100000"/>
-              <a:buFont typeface="Calibri" pitchFamily="34" charset="0"/>
-              <a:buChar char="•"/>
-            </a:pPr>
-            <a:r>
-              <a:rPr lang="en-US" sz="1100" dirty="0">
-                <a:solidFill>
-                  <a:srgbClr val="566576"/>
-                </a:solidFill>
-                <a:latin typeface="Calibri" pitchFamily="34" charset="0"/>
-                <a:ea typeface="Calibri" pitchFamily="34" charset="-122"/>
-                <a:cs typeface="Calibri" pitchFamily="34" charset="-120"/>
-              </a:rPr>
-              <a:t>A naive trigger can be gamed (loop until something passes) — needs a stop rule</a:t>
-            </a:r>
-          </a:p>
-        </p:txBody>
-      </p:sp>
-      <p:sp>
-        <p:nvSpPr>
-          <p:cNvPr id="22" name="Text 17"/>
-          <p:cNvSpPr/>
-          <p:nvPr/>
-        </p:nvSpPr>
-        <p:spPr>
-          <a:xfrm>
-            <a:off x="640080" y="6473952"/>
-            <a:ext cx="7315200" cy="274320"/>
-          </a:xfrm>
-          <a:prstGeom prst="rect">
-            <a:avLst/>
-          </a:prstGeom>
-          <a:noFill/>
-          <a:ln/>
-        </p:spPr>
-        <p:txBody>
-          <a:bodyPr wrap="square" lIns="0" tIns="0" rIns="0" bIns="0" rtlCol="0" anchor="ctr"/>
-          <a:lstStyle/>
-          <a:p>
-            <a:pPr marL="0" indent="0">
-              <a:buNone/>
-            </a:pPr>
-            <a:r>
-              <a:rPr lang="en-US" sz="900" dirty="0">
-                <a:solidFill>
-                  <a:srgbClr val="93A1B2"/>
-                </a:solidFill>
-                <a:latin typeface="Calibri" pitchFamily="34" charset="0"/>
-                <a:ea typeface="Calibri" pitchFamily="34" charset="-122"/>
-                <a:cs typeface="Calibri" pitchFamily="34" charset="-120"/>
-              </a:rPr>
-              <a:t>Deep Research Agent   ·   Neha Anna John</a:t>
-            </a:r>
-            <a:endParaRPr lang="en-US" sz="900" dirty="0"/>
-          </a:p>
-        </p:txBody>
-      </p:sp>
-      <p:sp>
-        <p:nvSpPr>
-          <p:cNvPr id="23" name="Text 18"/>
           <p:cNvSpPr/>
           <p:nvPr/>
         </p:nvSpPr>
@@ -32393,6 +33936,671 @@
 
 <file path=ppt/slides/slide30.xml><?xml version="1.0" encoding="utf-8"?>
 <p:sld xmlns:a="http://schemas.openxmlformats.org/drawingml/2006/main" xmlns:r="http://schemas.openxmlformats.org/officeDocument/2006/relationships" xmlns:p="http://schemas.openxmlformats.org/presentationml/2006/main">
+  <p:cSld name="Slide 29">
+    <p:bg>
+      <p:bgPr>
+        <a:solidFill>
+          <a:srgbClr val="F4F6F9"/>
+        </a:solidFill>
+        <a:effectLst/>
+      </p:bgPr>
+    </p:bg>
+    <p:spTree>
+      <p:nvGrpSpPr>
+        <p:cNvPr id="1" name=""/>
+        <p:cNvGrpSpPr/>
+        <p:nvPr/>
+      </p:nvGrpSpPr>
+      <p:grpSpPr>
+        <a:xfrm>
+          <a:off x="0" y="0"/>
+          <a:ext cx="0" cy="0"/>
+          <a:chOff x="0" y="0"/>
+          <a:chExt cx="0" cy="0"/>
+        </a:xfrm>
+      </p:grpSpPr>
+      <p:sp>
+        <p:nvSpPr>
+          <p:cNvPr id="2" name="Shape 0"/>
+          <p:cNvSpPr/>
+          <p:nvPr/>
+        </p:nvSpPr>
+        <p:spPr>
+          <a:xfrm>
+            <a:off x="640080" y="475488"/>
+            <a:ext cx="329184" cy="329184"/>
+          </a:xfrm>
+          <a:prstGeom prst="roundRect">
+            <a:avLst>
+              <a:gd name="adj" fmla="val 19444"/>
+            </a:avLst>
+          </a:prstGeom>
+          <a:solidFill>
+            <a:srgbClr val="0D9488"/>
+          </a:solidFill>
+          <a:ln/>
+        </p:spPr>
+        <p:txBody>
+          <a:bodyPr/>
+          <a:lstStyle/>
+          <a:p>
+            <a:endParaRPr lang="en-US"/>
+          </a:p>
+        </p:txBody>
+      </p:sp>
+      <p:sp>
+        <p:nvSpPr>
+          <p:cNvPr id="3" name="Text 1"/>
+          <p:cNvSpPr/>
+          <p:nvPr/>
+        </p:nvSpPr>
+        <p:spPr>
+          <a:xfrm>
+            <a:off x="640080" y="475488"/>
+            <a:ext cx="329184" cy="329184"/>
+          </a:xfrm>
+          <a:prstGeom prst="rect">
+            <a:avLst/>
+          </a:prstGeom>
+          <a:noFill/>
+          <a:ln/>
+        </p:spPr>
+        <p:txBody>
+          <a:bodyPr wrap="square" lIns="0" tIns="0" rIns="0" bIns="0" rtlCol="0" anchor="ctr"/>
+          <a:lstStyle/>
+          <a:p>
+            <a:pPr marL="0" indent="0" algn="ctr">
+              <a:buNone/>
+            </a:pPr>
+            <a:r>
+              <a:rPr lang="en-US" sz="1500" b="1" dirty="0">
+                <a:solidFill>
+                  <a:srgbClr val="FFFFFF"/>
+                </a:solidFill>
+                <a:latin typeface="Calibri" pitchFamily="34" charset="0"/>
+                <a:ea typeface="Calibri" pitchFamily="34" charset="-122"/>
+                <a:cs typeface="Calibri" pitchFamily="34" charset="-120"/>
+              </a:rPr>
+              <a:t>9</a:t>
+            </a:r>
+            <a:endParaRPr lang="en-US" sz="1500" dirty="0"/>
+          </a:p>
+        </p:txBody>
+      </p:sp>
+      <p:sp>
+        <p:nvSpPr>
+          <p:cNvPr id="4" name="Text 2"/>
+          <p:cNvSpPr/>
+          <p:nvPr/>
+        </p:nvSpPr>
+        <p:spPr>
+          <a:xfrm>
+            <a:off x="1097280" y="475488"/>
+            <a:ext cx="8229600" cy="329184"/>
+          </a:xfrm>
+          <a:prstGeom prst="rect">
+            <a:avLst/>
+          </a:prstGeom>
+          <a:noFill/>
+          <a:ln/>
+        </p:spPr>
+        <p:txBody>
+          <a:bodyPr wrap="square" lIns="0" tIns="0" rIns="0" bIns="0" rtlCol="0" anchor="ctr"/>
+          <a:lstStyle/>
+          <a:p>
+            <a:pPr marL="0" indent="0">
+              <a:buNone/>
+            </a:pPr>
+            <a:r>
+              <a:rPr lang="en-US" sz="1250" b="1" kern="0" spc="240" dirty="0">
+                <a:solidFill>
+                  <a:srgbClr val="0D9488"/>
+                </a:solidFill>
+                <a:latin typeface="Calibri" pitchFamily="34" charset="0"/>
+                <a:ea typeface="Calibri" pitchFamily="34" charset="-122"/>
+                <a:cs typeface="Calibri" pitchFamily="34" charset="-120"/>
+              </a:rPr>
+              <a:t>EXTENSIONS</a:t>
+            </a:r>
+            <a:endParaRPr lang="en-US" sz="1250" dirty="0"/>
+          </a:p>
+        </p:txBody>
+      </p:sp>
+      <p:sp>
+        <p:nvSpPr>
+          <p:cNvPr id="5" name="Text 3"/>
+          <p:cNvSpPr/>
+          <p:nvPr/>
+        </p:nvSpPr>
+        <p:spPr>
+          <a:xfrm>
+            <a:off x="640080" y="841248"/>
+            <a:ext cx="10911535" cy="822960"/>
+          </a:xfrm>
+          <a:prstGeom prst="rect">
+            <a:avLst/>
+          </a:prstGeom>
+          <a:noFill/>
+          <a:ln/>
+        </p:spPr>
+        <p:txBody>
+          <a:bodyPr wrap="square" lIns="0" tIns="0" rIns="0" bIns="0" rtlCol="0" anchor="t"/>
+          <a:lstStyle/>
+          <a:p>
+            <a:pPr marL="0" indent="0">
+              <a:buNone/>
+            </a:pPr>
+            <a:r>
+              <a:rPr lang="en-US" sz="3000" b="1" dirty="0">
+                <a:solidFill>
+                  <a:srgbClr val="16202E"/>
+                </a:solidFill>
+                <a:latin typeface="Calibri" pitchFamily="34" charset="0"/>
+                <a:ea typeface="Calibri" pitchFamily="34" charset="-122"/>
+                <a:cs typeface="Calibri" pitchFamily="34" charset="-120"/>
+              </a:rPr>
+              <a:t>Adaptive retrieval</a:t>
+            </a:r>
+            <a:endParaRPr lang="en-US" sz="3000" dirty="0"/>
+          </a:p>
+        </p:txBody>
+      </p:sp>
+      <p:sp>
+        <p:nvSpPr>
+          <p:cNvPr id="600" name="Intro"/>
+          <p:cNvSpPr txBox="1"/>
+          <p:nvPr/>
+        </p:nvSpPr>
+        <p:spPr>
+          <a:xfrm>
+            <a:off x="640080" y="1590000"/>
+            <a:ext cx="10911535" cy="980000"/>
+          </a:xfrm>
+          <a:prstGeom prst="rect">
+            <a:avLst/>
+          </a:prstGeom>
+        </p:spPr>
+        <p:txBody>
+          <a:bodyPr wrap="square" lIns="0" tIns="0" rIns="0" bIns="0" rtlCol="0" anchor="t"/>
+          <a:lstStyle/>
+          <a:p>
+            <a:pPr marL="0" indent="0">
+              <a:lnSpc>
+                <a:spcPct val="106000"/>
+              </a:lnSpc>
+              <a:buNone/>
+            </a:pPr>
+            <a:r>
+              <a:rPr lang="en-US" sz="1200" b="1" dirty="0">
+                <a:solidFill>
+                  <a:srgbClr val="0D9488"/>
+                </a:solidFill>
+                <a:latin typeface="Calibri" pitchFamily="34" charset="0"/>
+                <a:ea typeface="Calibri" pitchFamily="34" charset="-122"/>
+                <a:cs typeface="Calibri" pitchFamily="34" charset="-120"/>
+              </a:rPr>
+              <a:t>What it is — </a:t>
+            </a:r>
+            <a:r>
+              <a:rPr lang="en-US" sz="1200" dirty="0">
+                <a:solidFill>
+                  <a:srgbClr val="566576"/>
+                </a:solidFill>
+                <a:latin typeface="Calibri" pitchFamily="34" charset="0"/>
+                <a:ea typeface="Calibri" pitchFamily="34" charset="-122"/>
+                <a:cs typeface="Calibri" pitchFamily="34" charset="-120"/>
+              </a:rPr>
+              <a:t>replace the fixed retrieval policy with one that decides when and how to search again — multiple engines, routing by question type, and re-querying when the verifier flags weak evidence.</a:t>
+            </a:r>
+          </a:p>
+          <a:p>
+            <a:pPr marL="0" indent="0">
+              <a:spcBef>
+                <a:spcPts val="600"/>
+              </a:spcBef>
+              <a:buNone/>
+            </a:pPr>
+            <a:r>
+              <a:rPr lang="en-US" sz="1200" b="1" dirty="0">
+                <a:solidFill>
+                  <a:srgbClr val="0D9488"/>
+                </a:solidFill>
+                <a:latin typeface="Calibri" pitchFamily="34" charset="0"/>
+                <a:ea typeface="Calibri" pitchFamily="34" charset="-122"/>
+                <a:cs typeface="Calibri" pitchFamily="34" charset="-120"/>
+              </a:rPr>
+              <a:t>How it builds on this work — </a:t>
+            </a:r>
+            <a:r>
+              <a:rPr lang="en-US" sz="1200" dirty="0">
+                <a:solidFill>
+                  <a:srgbClr val="566576"/>
+                </a:solidFill>
+                <a:latin typeface="Calibri" pitchFamily="34" charset="0"/>
+                <a:ea typeface="Calibri" pitchFamily="34" charset="-122"/>
+                <a:cs typeface="Calibri" pitchFamily="34" charset="-120"/>
+              </a:rPr>
+              <a:t>the trained verifier already produces a per-claim support signal; that signal becomes the trigger for another retrieval round.</a:t>
+            </a:r>
+          </a:p>
+        </p:txBody>
+      </p:sp>
+      <p:sp>
+        <p:nvSpPr>
+          <p:cNvPr id="610" name="Strengths BG"/>
+          <p:cNvSpPr/>
+          <p:nvPr/>
+        </p:nvSpPr>
+        <p:spPr>
+          <a:xfrm>
+            <a:off x="640080" y="2660000"/>
+            <a:ext cx="5300320" cy="2880000"/>
+          </a:xfrm>
+          <a:prstGeom prst="roundRect">
+            <a:avLst>
+              <a:gd name="adj" fmla="val 3500"/>
+            </a:avLst>
+          </a:prstGeom>
+          <a:solidFill>
+            <a:srgbClr val="FFFFFF"/>
+          </a:solidFill>
+          <a:ln w="9525">
+            <a:solidFill>
+              <a:srgbClr val="D6DEE7"/>
+            </a:solidFill>
+          </a:ln>
+        </p:spPr>
+        <p:txBody>
+          <a:bodyPr/>
+          <a:lstStyle/>
+          <a:p>
+            <a:pPr>
+              <a:buNone/>
+            </a:pPr>
+            <a:endParaRPr lang="en-US"/>
+          </a:p>
+        </p:txBody>
+      </p:sp>
+      <p:sp>
+        <p:nvSpPr>
+          <p:cNvPr id="611" name="Strengths Head"/>
+          <p:cNvSpPr txBox="1"/>
+          <p:nvPr/>
+        </p:nvSpPr>
+        <p:spPr>
+          <a:xfrm>
+            <a:off x="920080" y="2860000"/>
+            <a:ext cx="4740320" cy="360000"/>
+          </a:xfrm>
+          <a:prstGeom prst="rect">
+            <a:avLst/>
+          </a:prstGeom>
+        </p:spPr>
+        <p:txBody>
+          <a:bodyPr wrap="square" lIns="0" tIns="0" rIns="0" bIns="0" rtlCol="0" anchor="t"/>
+          <a:lstStyle/>
+          <a:p>
+            <a:pPr marL="0" indent="0">
+              <a:buNone/>
+            </a:pPr>
+            <a:r>
+              <a:rPr lang="en-US" sz="1300" b="1" dirty="0">
+                <a:solidFill>
+                  <a:srgbClr val="1F9D57"/>
+                </a:solidFill>
+                <a:latin typeface="Calibri" pitchFamily="34" charset="0"/>
+                <a:ea typeface="Calibri" pitchFamily="34" charset="-122"/>
+                <a:cs typeface="Calibri" pitchFamily="34" charset="-120"/>
+              </a:rPr>
+              <a:t>Strengths</a:t>
+            </a:r>
+          </a:p>
+        </p:txBody>
+      </p:sp>
+      <p:sp>
+        <p:nvSpPr>
+          <p:cNvPr id="612" name="Strengths Bullets"/>
+          <p:cNvSpPr txBox="1"/>
+          <p:nvPr/>
+        </p:nvSpPr>
+        <p:spPr>
+          <a:xfrm>
+            <a:off x="920080" y="3320000"/>
+            <a:ext cx="4740320" cy="2060000"/>
+          </a:xfrm>
+          <a:prstGeom prst="rect">
+            <a:avLst/>
+          </a:prstGeom>
+        </p:spPr>
+        <p:txBody>
+          <a:bodyPr wrap="square" lIns="0" tIns="0" rIns="0" bIns="0" rtlCol="0" anchor="t"/>
+          <a:lstStyle/>
+          <a:p>
+            <a:pPr marL="200000" indent="-200000">
+              <a:lnSpc>
+                <a:spcPct val="106000"/>
+              </a:lnSpc>
+              <a:spcAft>
+                <a:spcPts val="900"/>
+              </a:spcAft>
+              <a:buSzPct val="100000"/>
+              <a:buFont typeface="Calibri" pitchFamily="34" charset="0"/>
+              <a:buChar char="•"/>
+            </a:pPr>
+            <a:r>
+              <a:rPr lang="en-US" sz="1100" dirty="0">
+                <a:solidFill>
+                  <a:srgbClr val="566576"/>
+                </a:solidFill>
+                <a:latin typeface="Calibri" pitchFamily="34" charset="0"/>
+                <a:ea typeface="Calibri" pitchFamily="34" charset="-122"/>
+                <a:cs typeface="Calibri" pitchFamily="34" charset="-120"/>
+              </a:rPr>
+              <a:t>Directly raises the coverage ceiling identified earlier</a:t>
+            </a:r>
+          </a:p>
+          <a:p>
+            <a:pPr marL="200000" indent="-200000">
+              <a:lnSpc>
+                <a:spcPct val="106000"/>
+              </a:lnSpc>
+              <a:spcAft>
+                <a:spcPts val="900"/>
+              </a:spcAft>
+              <a:buSzPct val="100000"/>
+              <a:buFont typeface="Calibri" pitchFamily="34" charset="0"/>
+              <a:buChar char="•"/>
+            </a:pPr>
+            <a:r>
+              <a:rPr lang="en-US" sz="1100" dirty="0">
+                <a:solidFill>
+                  <a:srgbClr val="566576"/>
+                </a:solidFill>
+                <a:latin typeface="Calibri" pitchFamily="34" charset="0"/>
+                <a:ea typeface="Calibri" pitchFamily="34" charset="-122"/>
+                <a:cs typeface="Calibri" pitchFamily="34" charset="-120"/>
+              </a:rPr>
+              <a:t>Reuses the existing verifier signal — no new reward model needed</a:t>
+            </a:r>
+          </a:p>
+          <a:p>
+            <a:pPr marL="200000" indent="-200000">
+              <a:lnSpc>
+                <a:spcPct val="106000"/>
+              </a:lnSpc>
+              <a:spcAft>
+                <a:spcPts val="900"/>
+              </a:spcAft>
+              <a:buSzPct val="100000"/>
+              <a:buFont typeface="Calibri" pitchFamily="34" charset="0"/>
+              <a:buChar char="•"/>
+            </a:pPr>
+            <a:r>
+              <a:rPr lang="en-US" sz="1100" dirty="0">
+                <a:solidFill>
+                  <a:srgbClr val="566576"/>
+                </a:solidFill>
+                <a:latin typeface="Calibri" pitchFamily="34" charset="0"/>
+                <a:ea typeface="Calibri" pitchFamily="34" charset="-122"/>
+                <a:cs typeface="Calibri" pitchFamily="34" charset="-120"/>
+              </a:rPr>
+              <a:t>Routing by question type sends each sub-query to the best engine</a:t>
+            </a:r>
+          </a:p>
+        </p:txBody>
+      </p:sp>
+      <p:sp>
+        <p:nvSpPr>
+          <p:cNvPr id="620" name="Tradeoffs BG"/>
+          <p:cNvSpPr/>
+          <p:nvPr/>
+        </p:nvSpPr>
+        <p:spPr>
+          <a:xfrm>
+            <a:off x="6251296" y="2660000"/>
+            <a:ext cx="5300320" cy="2880000"/>
+          </a:xfrm>
+          <a:prstGeom prst="roundRect">
+            <a:avLst>
+              <a:gd name="adj" fmla="val 3500"/>
+            </a:avLst>
+          </a:prstGeom>
+          <a:solidFill>
+            <a:srgbClr val="FFFFFF"/>
+          </a:solidFill>
+          <a:ln w="9525">
+            <a:solidFill>
+              <a:srgbClr val="D6DEE7"/>
+            </a:solidFill>
+          </a:ln>
+        </p:spPr>
+        <p:txBody>
+          <a:bodyPr/>
+          <a:lstStyle/>
+          <a:p>
+            <a:pPr>
+              <a:buNone/>
+            </a:pPr>
+            <a:endParaRPr lang="en-US"/>
+          </a:p>
+        </p:txBody>
+      </p:sp>
+      <p:sp>
+        <p:nvSpPr>
+          <p:cNvPr id="621" name="Tradeoffs Head"/>
+          <p:cNvSpPr txBox="1"/>
+          <p:nvPr/>
+        </p:nvSpPr>
+        <p:spPr>
+          <a:xfrm>
+            <a:off x="6531296" y="2860000"/>
+            <a:ext cx="4740320" cy="360000"/>
+          </a:xfrm>
+          <a:prstGeom prst="rect">
+            <a:avLst/>
+          </a:prstGeom>
+        </p:spPr>
+        <p:txBody>
+          <a:bodyPr wrap="square" lIns="0" tIns="0" rIns="0" bIns="0" rtlCol="0" anchor="t"/>
+          <a:lstStyle/>
+          <a:p>
+            <a:pPr marL="0" indent="0">
+              <a:buNone/>
+            </a:pPr>
+            <a:r>
+              <a:rPr lang="en-US" sz="1300" b="1" dirty="0">
+                <a:solidFill>
+                  <a:srgbClr val="B07A0C"/>
+                </a:solidFill>
+                <a:latin typeface="Calibri" pitchFamily="34" charset="0"/>
+                <a:ea typeface="Calibri" pitchFamily="34" charset="-122"/>
+                <a:cs typeface="Calibri" pitchFamily="34" charset="-120"/>
+              </a:rPr>
+              <a:t>Trade-offs / risks</a:t>
+            </a:r>
+          </a:p>
+        </p:txBody>
+      </p:sp>
+      <p:sp>
+        <p:nvSpPr>
+          <p:cNvPr id="622" name="Tradeoffs Bullets"/>
+          <p:cNvSpPr txBox="1"/>
+          <p:nvPr/>
+        </p:nvSpPr>
+        <p:spPr>
+          <a:xfrm>
+            <a:off x="6531296" y="3320000"/>
+            <a:ext cx="4740320" cy="2060000"/>
+          </a:xfrm>
+          <a:prstGeom prst="rect">
+            <a:avLst/>
+          </a:prstGeom>
+        </p:spPr>
+        <p:txBody>
+          <a:bodyPr wrap="square" lIns="0" tIns="0" rIns="0" bIns="0" rtlCol="0" anchor="t"/>
+          <a:lstStyle/>
+          <a:p>
+            <a:pPr marL="200000" indent="-200000">
+              <a:lnSpc>
+                <a:spcPct val="106000"/>
+              </a:lnSpc>
+              <a:spcAft>
+                <a:spcPts val="900"/>
+              </a:spcAft>
+              <a:buSzPct val="100000"/>
+              <a:buFont typeface="Calibri" pitchFamily="34" charset="0"/>
+              <a:buChar char="•"/>
+            </a:pPr>
+            <a:r>
+              <a:rPr lang="en-US" sz="1100" dirty="0">
+                <a:solidFill>
+                  <a:srgbClr val="566576"/>
+                </a:solidFill>
+                <a:latin typeface="Calibri" pitchFamily="34" charset="0"/>
+                <a:ea typeface="Calibri" pitchFamily="34" charset="-122"/>
+                <a:cs typeface="Calibri" pitchFamily="34" charset="-120"/>
+              </a:rPr>
+              <a:t>Cannot beat the absolute search ceiling — if evidence is not indexed, smarter search does not help</a:t>
+            </a:r>
+          </a:p>
+          <a:p>
+            <a:pPr marL="200000" indent="-200000">
+              <a:lnSpc>
+                <a:spcPct val="106000"/>
+              </a:lnSpc>
+              <a:spcAft>
+                <a:spcPts val="900"/>
+              </a:spcAft>
+              <a:buSzPct val="100000"/>
+              <a:buFont typeface="Calibri" pitchFamily="34" charset="0"/>
+              <a:buChar char="•"/>
+            </a:pPr>
+            <a:r>
+              <a:rPr lang="en-US" sz="1100" dirty="0">
+                <a:solidFill>
+                  <a:srgbClr val="566576"/>
+                </a:solidFill>
+                <a:latin typeface="Calibri" pitchFamily="34" charset="0"/>
+                <a:ea typeface="Calibri" pitchFamily="34" charset="-122"/>
+                <a:cs typeface="Calibri" pitchFamily="34" charset="-120"/>
+              </a:rPr>
+              <a:t>Re-querying adds latency and cost per question</a:t>
+            </a:r>
+          </a:p>
+          <a:p>
+            <a:pPr marL="200000" indent="-200000">
+              <a:lnSpc>
+                <a:spcPct val="106000"/>
+              </a:lnSpc>
+              <a:spcAft>
+                <a:spcPts val="900"/>
+              </a:spcAft>
+              <a:buSzPct val="100000"/>
+              <a:buFont typeface="Calibri" pitchFamily="34" charset="0"/>
+              <a:buChar char="•"/>
+            </a:pPr>
+            <a:r>
+              <a:rPr lang="en-US" sz="1100" dirty="0">
+                <a:solidFill>
+                  <a:srgbClr val="566576"/>
+                </a:solidFill>
+                <a:latin typeface="Calibri" pitchFamily="34" charset="0"/>
+                <a:ea typeface="Calibri" pitchFamily="34" charset="-122"/>
+                <a:cs typeface="Calibri" pitchFamily="34" charset="-120"/>
+              </a:rPr>
+              <a:t>A naive trigger can be gamed (loop until something passes) — needs a stop rule</a:t>
+            </a:r>
+          </a:p>
+        </p:txBody>
+      </p:sp>
+      <p:sp>
+        <p:nvSpPr>
+          <p:cNvPr id="22" name="Text 17"/>
+          <p:cNvSpPr/>
+          <p:nvPr/>
+        </p:nvSpPr>
+        <p:spPr>
+          <a:xfrm>
+            <a:off x="640080" y="6473952"/>
+            <a:ext cx="7315200" cy="274320"/>
+          </a:xfrm>
+          <a:prstGeom prst="rect">
+            <a:avLst/>
+          </a:prstGeom>
+          <a:noFill/>
+          <a:ln/>
+        </p:spPr>
+        <p:txBody>
+          <a:bodyPr wrap="square" lIns="0" tIns="0" rIns="0" bIns="0" rtlCol="0" anchor="ctr"/>
+          <a:lstStyle/>
+          <a:p>
+            <a:pPr marL="0" indent="0">
+              <a:buNone/>
+            </a:pPr>
+            <a:r>
+              <a:rPr lang="en-US" sz="900" dirty="0">
+                <a:solidFill>
+                  <a:srgbClr val="93A1B2"/>
+                </a:solidFill>
+                <a:latin typeface="Calibri" pitchFamily="34" charset="0"/>
+                <a:ea typeface="Calibri" pitchFamily="34" charset="-122"/>
+                <a:cs typeface="Calibri" pitchFamily="34" charset="-120"/>
+              </a:rPr>
+              <a:t>Deep Research Agent   ·   Neha Anna John</a:t>
+            </a:r>
+            <a:endParaRPr lang="en-US" sz="900" dirty="0"/>
+          </a:p>
+        </p:txBody>
+      </p:sp>
+      <p:sp>
+        <p:nvSpPr>
+          <p:cNvPr id="23" name="Text 18"/>
+          <p:cNvSpPr/>
+          <p:nvPr/>
+        </p:nvSpPr>
+        <p:spPr>
+          <a:xfrm>
+            <a:off x="11002975" y="6473952"/>
+            <a:ext cx="548640" cy="274320"/>
+          </a:xfrm>
+          <a:prstGeom prst="rect">
+            <a:avLst/>
+          </a:prstGeom>
+          <a:noFill/>
+          <a:ln/>
+        </p:spPr>
+        <p:txBody>
+          <a:bodyPr wrap="square" lIns="0" tIns="0" rIns="0" bIns="0" rtlCol="0" anchor="ctr"/>
+          <a:lstStyle/>
+          <a:p>
+            <a:pPr marL="0" indent="0" algn="r">
+              <a:buNone/>
+            </a:pPr>
+            <a:r>
+              <a:rPr lang="en-US" sz="950" b="1" dirty="0">
+                <a:solidFill>
+                  <a:srgbClr val="93A1B2"/>
+                </a:solidFill>
+                <a:latin typeface="Calibri" pitchFamily="34" charset="0"/>
+                <a:ea typeface="Calibri" pitchFamily="34" charset="-122"/>
+                <a:cs typeface="Calibri" pitchFamily="34" charset="-120"/>
+              </a:rPr>
+              <a:t>29</a:t>
+            </a:r>
+            <a:endParaRPr lang="en-US" sz="950" dirty="0"/>
+          </a:p>
+        </p:txBody>
+      </p:sp>
+    </p:spTree>
+  </p:cSld>
+  <p:clrMapOvr>
+    <a:masterClrMapping/>
+  </p:clrMapOvr>
+</p:sld>
+</file>
+
+<file path=ppt/slides/slide31.xml><?xml version="1.0" encoding="utf-8"?>
+<p:sld xmlns:a="http://schemas.openxmlformats.org/drawingml/2006/main" xmlns:r="http://schemas.openxmlformats.org/officeDocument/2006/relationships" xmlns:p="http://schemas.openxmlformats.org/presentationml/2006/main">
   <p:cSld name="Slide 30">
     <p:bg>
       <p:bgPr>
@@ -33042,7 +35250,7 @@
                 <a:ea typeface="Calibri" pitchFamily="34" charset="-122"/>
                 <a:cs typeface="Calibri" pitchFamily="34" charset="-120"/>
               </a:rPr>
-              <a:t>29</a:t>
+              <a:t>30</a:t>
             </a:r>
             <a:endParaRPr lang="en-US" sz="950" dirty="0"/>
           </a:p>
@@ -33056,7 +35264,7 @@
 </p:sld>
 </file>
 
-<file path=ppt/slides/slide31.xml><?xml version="1.0" encoding="utf-8"?>
+<file path=ppt/slides/slide32.xml><?xml version="1.0" encoding="utf-8"?>
 <p:sld xmlns:a="http://schemas.openxmlformats.org/drawingml/2006/main" xmlns:r="http://schemas.openxmlformats.org/officeDocument/2006/relationships" xmlns:p="http://schemas.openxmlformats.org/presentationml/2006/main">
   <p:cSld name="Slide 31">
     <p:bg>

</xml_diff>